<commit_message>
Remove answer reveal from stack setup slide
</commit_message>
<xml_diff>
--- a/public/presentations/CS211_Recitation_7.pptx
+++ b/public/presentations/CS211_Recitation_7.pptx
@@ -2,45 +2,45 @@
 <file path=ppt/presentation.xml><?xml version="1.0" encoding="utf-8"?>
 <p:presentation xmlns:p="http://schemas.openxmlformats.org/presentationml/2006/main" embedTrueTypeFonts="1" saveSubsetFonts="0">
   <p:sldMasterIdLst>
-    <p:sldMasterId xmlns:r="http://schemas.openxmlformats.org/officeDocument/2006/relationships" id="2147483648" r:id="R9f36d197724a4d4a"/>
+    <p:sldMasterId xmlns:r="http://schemas.openxmlformats.org/officeDocument/2006/relationships" id="2147483648" r:id="R0e7a8a5136224fde"/>
   </p:sldMasterIdLst>
   <p:notesMasterIdLst>
-    <p:notesMasterId xmlns:r="http://schemas.openxmlformats.org/officeDocument/2006/relationships" r:id="Rd5d666ad25704bc3"/>
+    <p:notesMasterId xmlns:r="http://schemas.openxmlformats.org/officeDocument/2006/relationships" r:id="R30214bec0cbd41fb"/>
   </p:notesMasterIdLst>
   <p:sldIdLst>
-    <p:sldId xmlns:r="http://schemas.openxmlformats.org/officeDocument/2006/relationships" id="256" r:id="R54c9652d857f4567"/>
-    <p:sldId xmlns:r="http://schemas.openxmlformats.org/officeDocument/2006/relationships" id="257" r:id="R7ff626f778064efa"/>
-    <p:sldId xmlns:r="http://schemas.openxmlformats.org/officeDocument/2006/relationships" id="258" r:id="R86cd73b5a894491f"/>
-    <p:sldId xmlns:r="http://schemas.openxmlformats.org/officeDocument/2006/relationships" id="259" r:id="Rb538f45a78b24926"/>
-    <p:sldId xmlns:r="http://schemas.openxmlformats.org/officeDocument/2006/relationships" id="260" r:id="R0e9cba78e623487d"/>
-    <p:sldId xmlns:r="http://schemas.openxmlformats.org/officeDocument/2006/relationships" id="261" r:id="Rddcc95b7e95a4458"/>
-    <p:sldId xmlns:r="http://schemas.openxmlformats.org/officeDocument/2006/relationships" id="262" r:id="R2449be60f7f449b8"/>
-    <p:sldId xmlns:r="http://schemas.openxmlformats.org/officeDocument/2006/relationships" id="263" r:id="R51b6d8e6b1054610"/>
-    <p:sldId xmlns:r="http://schemas.openxmlformats.org/officeDocument/2006/relationships" id="264" r:id="Ra030d658446b4f7e"/>
-    <p:sldId xmlns:r="http://schemas.openxmlformats.org/officeDocument/2006/relationships" id="265" r:id="Rc2ef2d59ec4e498d"/>
-    <p:sldId xmlns:r="http://schemas.openxmlformats.org/officeDocument/2006/relationships" id="266" r:id="R207aabbf8b34457f"/>
-    <p:sldId xmlns:r="http://schemas.openxmlformats.org/officeDocument/2006/relationships" id="267" r:id="Rb9a4b445b6124fc4"/>
-    <p:sldId xmlns:r="http://schemas.openxmlformats.org/officeDocument/2006/relationships" id="268" r:id="Rb3250c260c3243d8"/>
-    <p:sldId xmlns:r="http://schemas.openxmlformats.org/officeDocument/2006/relationships" id="269" r:id="Re4ba086785fa4b48"/>
-    <p:sldId xmlns:r="http://schemas.openxmlformats.org/officeDocument/2006/relationships" id="270" r:id="R829f8f6183d94ce9"/>
-    <p:sldId xmlns:r="http://schemas.openxmlformats.org/officeDocument/2006/relationships" id="271" r:id="Re13015b6302241df"/>
-    <p:sldId xmlns:r="http://schemas.openxmlformats.org/officeDocument/2006/relationships" id="272" r:id="R832e9f68a76d400c"/>
-    <p:sldId xmlns:r="http://schemas.openxmlformats.org/officeDocument/2006/relationships" id="273" r:id="Ra80fd736b9d34c62"/>
-    <p:sldId xmlns:r="http://schemas.openxmlformats.org/officeDocument/2006/relationships" id="274" r:id="R896e2b4199be4983"/>
-    <p:sldId xmlns:r="http://schemas.openxmlformats.org/officeDocument/2006/relationships" id="275" r:id="Rb39f62a315bd4ebd"/>
-    <p:sldId xmlns:r="http://schemas.openxmlformats.org/officeDocument/2006/relationships" id="276" r:id="Rca27ccde41e5411e"/>
-    <p:sldId xmlns:r="http://schemas.openxmlformats.org/officeDocument/2006/relationships" id="277" r:id="R0eade8bfe43c4a0c"/>
-    <p:sldId xmlns:r="http://schemas.openxmlformats.org/officeDocument/2006/relationships" id="278" r:id="R8789737889994fee"/>
+    <p:sldId xmlns:r="http://schemas.openxmlformats.org/officeDocument/2006/relationships" id="256" r:id="R54a419f5acf44c12"/>
+    <p:sldId xmlns:r="http://schemas.openxmlformats.org/officeDocument/2006/relationships" id="257" r:id="R49ac621a0d9b4676"/>
+    <p:sldId xmlns:r="http://schemas.openxmlformats.org/officeDocument/2006/relationships" id="258" r:id="Re4472a261d8542e8"/>
+    <p:sldId xmlns:r="http://schemas.openxmlformats.org/officeDocument/2006/relationships" id="259" r:id="R6c5dafd550964940"/>
+    <p:sldId xmlns:r="http://schemas.openxmlformats.org/officeDocument/2006/relationships" id="260" r:id="R0645639e024349e5"/>
+    <p:sldId xmlns:r="http://schemas.openxmlformats.org/officeDocument/2006/relationships" id="261" r:id="Rf8235a4e25294fb2"/>
+    <p:sldId xmlns:r="http://schemas.openxmlformats.org/officeDocument/2006/relationships" id="262" r:id="R3885ed69a77341ef"/>
+    <p:sldId xmlns:r="http://schemas.openxmlformats.org/officeDocument/2006/relationships" id="263" r:id="Rfed9f0f27eaa41a4"/>
+    <p:sldId xmlns:r="http://schemas.openxmlformats.org/officeDocument/2006/relationships" id="264" r:id="Rdb536370759844aa"/>
+    <p:sldId xmlns:r="http://schemas.openxmlformats.org/officeDocument/2006/relationships" id="265" r:id="Rd2500efbb61c4c85"/>
+    <p:sldId xmlns:r="http://schemas.openxmlformats.org/officeDocument/2006/relationships" id="266" r:id="R880313408f394e54"/>
+    <p:sldId xmlns:r="http://schemas.openxmlformats.org/officeDocument/2006/relationships" id="267" r:id="R02b1380f3bb64349"/>
+    <p:sldId xmlns:r="http://schemas.openxmlformats.org/officeDocument/2006/relationships" id="268" r:id="R7c461ae444dd4ab6"/>
+    <p:sldId xmlns:r="http://schemas.openxmlformats.org/officeDocument/2006/relationships" id="269" r:id="Rfa762dbcad7f49e7"/>
+    <p:sldId xmlns:r="http://schemas.openxmlformats.org/officeDocument/2006/relationships" id="270" r:id="R3a98809f153145e8"/>
+    <p:sldId xmlns:r="http://schemas.openxmlformats.org/officeDocument/2006/relationships" id="271" r:id="Rc548e0460ad84b13"/>
+    <p:sldId xmlns:r="http://schemas.openxmlformats.org/officeDocument/2006/relationships" id="272" r:id="Rf64c3155233f4a99"/>
+    <p:sldId xmlns:r="http://schemas.openxmlformats.org/officeDocument/2006/relationships" id="273" r:id="R1eba9e2d8d0a4517"/>
+    <p:sldId xmlns:r="http://schemas.openxmlformats.org/officeDocument/2006/relationships" id="274" r:id="R8a9da1a01da047c9"/>
+    <p:sldId xmlns:r="http://schemas.openxmlformats.org/officeDocument/2006/relationships" id="275" r:id="R8b1bfbc492a54323"/>
+    <p:sldId xmlns:r="http://schemas.openxmlformats.org/officeDocument/2006/relationships" id="276" r:id="Rbdcd86c0088a44ae"/>
+    <p:sldId xmlns:r="http://schemas.openxmlformats.org/officeDocument/2006/relationships" id="277" r:id="R5146a19a60344a08"/>
+    <p:sldId xmlns:r="http://schemas.openxmlformats.org/officeDocument/2006/relationships" id="278" r:id="Rc266c82505b24b05"/>
   </p:sldIdLst>
   <p:sldSz cx="12192000" cy="6858000"/>
   <p:notesSz cx="6858000" cy="9144000"/>
   <p:embeddedFontLst>
     <p:embeddedFont>
       <p:font typeface="OpenAI Sans"/>
-      <p:regular xmlns:r="http://schemas.openxmlformats.org/officeDocument/2006/relationships" r:id="R771a34c063ac4c1e"/>
-      <p:bold xmlns:r="http://schemas.openxmlformats.org/officeDocument/2006/relationships" r:id="R888c0e007df14941"/>
-      <p:italic xmlns:r="http://schemas.openxmlformats.org/officeDocument/2006/relationships" r:id="R22535a57c21c4405"/>
-      <p:boldItalic xmlns:r="http://schemas.openxmlformats.org/officeDocument/2006/relationships" r:id="Rfc48235d3be341b7"/>
+      <p:regular xmlns:r="http://schemas.openxmlformats.org/officeDocument/2006/relationships" r:id="Rc93f8612a50a40d7"/>
+      <p:bold xmlns:r="http://schemas.openxmlformats.org/officeDocument/2006/relationships" r:id="R7bcd55f6e24d44e8"/>
+      <p:italic xmlns:r="http://schemas.openxmlformats.org/officeDocument/2006/relationships" r:id="R04d937ebf9d84e42"/>
+      <p:boldItalic xmlns:r="http://schemas.openxmlformats.org/officeDocument/2006/relationships" r:id="Rebc70526097844a6"/>
     </p:embeddedFont>
   </p:embeddedFontLst>
   <p:defaultTextStyle>
@@ -3596,66 +3596,6 @@
             </a:r>
             <a:endParaRPr/>
           </a:p>
-          <a:p xmlns:a="http://schemas.openxmlformats.org/drawingml/2006/main">
-            <a:pPr marL="0" lvl="0" indent="0" algn="l">
-              <a:spcBef>
-                <a:spcPts val="0"/>
-              </a:spcBef>
-              <a:spcAft>
-                <a:spcPts val="0"/>
-              </a:spcAft>
-              <a:buNone/>
-            </a:pPr>
-            <a:r>
-              <a:t/>
-            </a:r>
-            <a:endParaRPr/>
-          </a:p>
-          <a:p xmlns:a="http://schemas.openxmlformats.org/drawingml/2006/main">
-            <a:pPr marL="0" lvl="0" indent="0" algn="l">
-              <a:spcBef>
-                <a:spcPts val="0"/>
-              </a:spcBef>
-              <a:spcAft>
-                <a:spcPts val="0"/>
-              </a:spcAft>
-              <a:buNone/>
-            </a:pPr>
-            <a:r>
-              <a:t>Answer: 1. subq $32, %rsp decreases RSP by 32, reserving 32 bytes below its previous position.</a:t>
-            </a:r>
-            <a:endParaRPr/>
-          </a:p>
-          <a:p xmlns:a="http://schemas.openxmlformats.org/drawingml/2006/main">
-            <a:pPr marL="0" lvl="0" indent="0" algn="l">
-              <a:spcBef>
-                <a:spcPts val="0"/>
-              </a:spcBef>
-              <a:spcAft>
-                <a:spcPts val="0"/>
-              </a:spcAft>
-              <a:buNone/>
-            </a:pPr>
-            <a:r>
-              <a:t/>
-            </a:r>
-            <a:endParaRPr/>
-          </a:p>
-          <a:p xmlns:a="http://schemas.openxmlformats.org/drawingml/2006/main">
-            <a:pPr marL="0" lvl="0" indent="0" algn="l">
-              <a:spcBef>
-                <a:spcPts val="0"/>
-              </a:spcBef>
-              <a:spcAft>
-                <a:spcPts val="0"/>
-              </a:spcAft>
-              <a:buNone/>
-            </a:pPr>
-            <a:r>
-              <a:t>2. movq %rbp, %rsp restores RSP to this frame’s base. popq restores the saved caller RBP. ret consumes the return address and resumes the caller.</a:t>
-            </a:r>
-            <a:endParaRPr/>
-          </a:p>
         </p:txBody>
       </p:sp>
       <p:sp>
@@ -6216,14 +6156,14 @@
   </p:cSld>
   <p:clrMap bg1="dk1" tx1="lt1" bg2="dk2" tx2="lt2" accent1="accent1" accent2="accent2" accent3="accent3" accent4="accent4" accent5="accent5" accent6="accent6" hlink="hlink" folHlink="folHlink"/>
   <p:sldLayoutIdLst>
-    <p:sldLayoutId xmlns:r="http://schemas.openxmlformats.org/officeDocument/2006/relationships" id="2147483649" r:id="R8cbee9d63ac0493d"/>
-    <p:sldLayoutId xmlns:r="http://schemas.openxmlformats.org/officeDocument/2006/relationships" id="2147483650" r:id="Ra7df42572436448a"/>
-    <p:sldLayoutId xmlns:r="http://schemas.openxmlformats.org/officeDocument/2006/relationships" id="2147483651" r:id="Rbfab4a536e864478"/>
-    <p:sldLayoutId xmlns:r="http://schemas.openxmlformats.org/officeDocument/2006/relationships" id="2147483652" r:id="R3ecd5b987e9a4df6"/>
-    <p:sldLayoutId xmlns:r="http://schemas.openxmlformats.org/officeDocument/2006/relationships" id="2147483653" r:id="R6ef1ced36c2b4611"/>
-    <p:sldLayoutId xmlns:r="http://schemas.openxmlformats.org/officeDocument/2006/relationships" id="2147483654" r:id="R4ad01fa022f4437f"/>
-    <p:sldLayoutId xmlns:r="http://schemas.openxmlformats.org/officeDocument/2006/relationships" id="2147483655" r:id="R5b7935eb90134c2b"/>
-    <p:sldLayoutId xmlns:r="http://schemas.openxmlformats.org/officeDocument/2006/relationships" id="2147483656" r:id="Re88146bd729e4b92"/>
+    <p:sldLayoutId xmlns:r="http://schemas.openxmlformats.org/officeDocument/2006/relationships" id="2147483649" r:id="R78d557211e4b4205"/>
+    <p:sldLayoutId xmlns:r="http://schemas.openxmlformats.org/officeDocument/2006/relationships" id="2147483650" r:id="R04fbee4d4c464775"/>
+    <p:sldLayoutId xmlns:r="http://schemas.openxmlformats.org/officeDocument/2006/relationships" id="2147483651" r:id="R75667768e0084791"/>
+    <p:sldLayoutId xmlns:r="http://schemas.openxmlformats.org/officeDocument/2006/relationships" id="2147483652" r:id="Re451ec1b75de41e1"/>
+    <p:sldLayoutId xmlns:r="http://schemas.openxmlformats.org/officeDocument/2006/relationships" id="2147483653" r:id="Re0d369c2f161460c"/>
+    <p:sldLayoutId xmlns:r="http://schemas.openxmlformats.org/officeDocument/2006/relationships" id="2147483654" r:id="R57b2f11281744806"/>
+    <p:sldLayoutId xmlns:r="http://schemas.openxmlformats.org/officeDocument/2006/relationships" id="2147483655" r:id="R10f7d0a00fee4c25"/>
+    <p:sldLayoutId xmlns:r="http://schemas.openxmlformats.org/officeDocument/2006/relationships" id="2147483656" r:id="R79d3cea4952e4313"/>
   </p:sldLayoutIdLst>
   <p:hf hdr="0" dt="0"/>
   <p:txStyles>
@@ -9094,7 +9034,7 @@
           <p:cNvPr id="534" name="">
             <a:extLst xmlns:a="http://schemas.openxmlformats.org/drawingml/2006/main">
               <a:ext uri="{FF2B5EF4-FFF2-40B4-BE49-F238E27FC236}">
-                <a16:creationId xmlns:a16="http://schemas.microsoft.com/office/drawing/2014/main" id="{6FCCE28B-7EFF-4B47-9B23-1FFD02537173}"/>
+                <a16:creationId xmlns:a16="http://schemas.microsoft.com/office/drawing/2014/main" id="{971C40B4-20AC-4450-9A51-A85F453F177B}"/>
               </a:ext>
             </a:extLst>
           </p:cNvPr>
@@ -9837,7 +9777,7 @@
           <p:cNvPr id="535" name="Takeaway">
             <a:extLst xmlns:a="http://schemas.openxmlformats.org/drawingml/2006/main">
               <a:ext uri="{FF2B5EF4-FFF2-40B4-BE49-F238E27FC236}">
-                <a16:creationId xmlns:a16="http://schemas.microsoft.com/office/drawing/2014/main" id="{537E36E0-0321-414D-A3FA-5D74279EA142}"/>
+                <a16:creationId xmlns:a16="http://schemas.microsoft.com/office/drawing/2014/main" id="{7FBE8C99-2F84-48F5-B843-49889E06CF14}"/>
               </a:ext>
             </a:extLst>
           </p:cNvPr>
@@ -11221,7 +11161,7 @@
           <p:cNvPr id="534" name="Takeaway">
             <a:extLst xmlns:a="http://schemas.openxmlformats.org/drawingml/2006/main">
               <a:ext uri="{FF2B5EF4-FFF2-40B4-BE49-F238E27FC236}">
-                <a16:creationId xmlns:a16="http://schemas.microsoft.com/office/drawing/2014/main" id="{7541806E-0771-4C2E-B28B-CC598DB3A81E}"/>
+                <a16:creationId xmlns:a16="http://schemas.microsoft.com/office/drawing/2014/main" id="{832D1CA6-F714-43F2-92AB-193FEC35CE41}"/>
               </a:ext>
             </a:extLst>
           </p:cNvPr>
@@ -12654,7 +12594,7 @@
           <p:cNvPr id="534" name="Takeaway">
             <a:extLst xmlns:a="http://schemas.openxmlformats.org/drawingml/2006/main">
               <a:ext uri="{FF2B5EF4-FFF2-40B4-BE49-F238E27FC236}">
-                <a16:creationId xmlns:a16="http://schemas.microsoft.com/office/drawing/2014/main" id="{6EB14764-E89D-4D28-8A57-779C4580CC62}"/>
+                <a16:creationId xmlns:a16="http://schemas.microsoft.com/office/drawing/2014/main" id="{B9374ABE-FFE3-48BB-BE72-8E7E710AE770}"/>
               </a:ext>
             </a:extLst>
           </p:cNvPr>
@@ -14136,7 +14076,7 @@
           <p:cNvPr id="534" name="Takeaway">
             <a:extLst xmlns:a="http://schemas.openxmlformats.org/drawingml/2006/main">
               <a:ext uri="{FF2B5EF4-FFF2-40B4-BE49-F238E27FC236}">
-                <a16:creationId xmlns:a16="http://schemas.microsoft.com/office/drawing/2014/main" id="{34FC27C5-CF90-4E1B-A15E-12D278FACD46}"/>
+                <a16:creationId xmlns:a16="http://schemas.microsoft.com/office/drawing/2014/main" id="{0185E7EE-2D1D-45DF-8068-D2D525BD8030}"/>
               </a:ext>
             </a:extLst>
           </p:cNvPr>
@@ -15519,7 +15459,7 @@
           <p:cNvPr id="534" name="">
             <a:extLst xmlns:a="http://schemas.openxmlformats.org/drawingml/2006/main">
               <a:ext uri="{FF2B5EF4-FFF2-40B4-BE49-F238E27FC236}">
-                <a16:creationId xmlns:a16="http://schemas.microsoft.com/office/drawing/2014/main" id="{04CEB5FA-2553-40CC-9FEE-5F7D2627E3B0}"/>
+                <a16:creationId xmlns:a16="http://schemas.microsoft.com/office/drawing/2014/main" id="{FB8DB4C9-6933-4726-8D17-04EFE20708EA}"/>
               </a:ext>
             </a:extLst>
           </p:cNvPr>
@@ -15879,7 +15819,7 @@
           <p:cNvPr id="535" name="Takeaway">
             <a:extLst xmlns:a="http://schemas.openxmlformats.org/drawingml/2006/main">
               <a:ext uri="{FF2B5EF4-FFF2-40B4-BE49-F238E27FC236}">
-                <a16:creationId xmlns:a16="http://schemas.microsoft.com/office/drawing/2014/main" id="{F2BAEB72-B926-4769-B419-C563C22B9E0B}"/>
+                <a16:creationId xmlns:a16="http://schemas.microsoft.com/office/drawing/2014/main" id="{E4C585EB-FCC5-4710-B805-C0B40B32A791}"/>
               </a:ext>
             </a:extLst>
           </p:cNvPr>
@@ -17329,7 +17269,7 @@
           <p:cNvPr id="534" name="Takeaway">
             <a:extLst xmlns:a="http://schemas.openxmlformats.org/drawingml/2006/main">
               <a:ext uri="{FF2B5EF4-FFF2-40B4-BE49-F238E27FC236}">
-                <a16:creationId xmlns:a16="http://schemas.microsoft.com/office/drawing/2014/main" id="{B7100F3D-9062-40E9-8E44-DBD36FB16D15}"/>
+                <a16:creationId xmlns:a16="http://schemas.microsoft.com/office/drawing/2014/main" id="{6742AE34-50CA-4D0F-A8FB-A294D37CF768}"/>
               </a:ext>
             </a:extLst>
           </p:cNvPr>
@@ -18729,7 +18669,7 @@
           <p:cNvPr id="534" name="Takeaway">
             <a:extLst xmlns:a="http://schemas.openxmlformats.org/drawingml/2006/main">
               <a:ext uri="{FF2B5EF4-FFF2-40B4-BE49-F238E27FC236}">
-                <a16:creationId xmlns:a16="http://schemas.microsoft.com/office/drawing/2014/main" id="{B6562FAC-C200-45B6-9B26-704ED2BFBFEE}"/>
+                <a16:creationId xmlns:a16="http://schemas.microsoft.com/office/drawing/2014/main" id="{F5C7BD72-255F-4EBC-AE26-AF106DC0323D}"/>
               </a:ext>
             </a:extLst>
           </p:cNvPr>
@@ -20179,7 +20119,7 @@
           <p:cNvPr id="534" name="Takeaway">
             <a:extLst xmlns:a="http://schemas.openxmlformats.org/drawingml/2006/main">
               <a:ext uri="{FF2B5EF4-FFF2-40B4-BE49-F238E27FC236}">
-                <a16:creationId xmlns:a16="http://schemas.microsoft.com/office/drawing/2014/main" id="{1F203D10-DDBF-4119-9822-23593C823BEC}"/>
+                <a16:creationId xmlns:a16="http://schemas.microsoft.com/office/drawing/2014/main" id="{4DF58262-EB23-4D35-8BD2-FBAEE31CB15B}"/>
               </a:ext>
             </a:extLst>
           </p:cNvPr>
@@ -21612,7 +21552,7 @@
           <p:cNvPr id="534" name="Takeaway">
             <a:extLst xmlns:a="http://schemas.openxmlformats.org/drawingml/2006/main">
               <a:ext uri="{FF2B5EF4-FFF2-40B4-BE49-F238E27FC236}">
-                <a16:creationId xmlns:a16="http://schemas.microsoft.com/office/drawing/2014/main" id="{4AAAD5DC-2B0D-4283-AD48-06D5987BBDC6}"/>
+                <a16:creationId xmlns:a16="http://schemas.microsoft.com/office/drawing/2014/main" id="{812A45D3-92CA-4E5D-BD87-4E21314A084A}"/>
               </a:ext>
             </a:extLst>
           </p:cNvPr>
@@ -23078,7 +23018,7 @@
           <p:cNvPr id="534" name="Takeaway">
             <a:extLst xmlns:a="http://schemas.openxmlformats.org/drawingml/2006/main">
               <a:ext uri="{FF2B5EF4-FFF2-40B4-BE49-F238E27FC236}">
-                <a16:creationId xmlns:a16="http://schemas.microsoft.com/office/drawing/2014/main" id="{A2F2FC1D-5904-4512-8FF8-96C4F550E745}"/>
+                <a16:creationId xmlns:a16="http://schemas.microsoft.com/office/drawing/2014/main" id="{A299AB3F-CAC7-45C6-B905-56803A147272}"/>
               </a:ext>
             </a:extLst>
           </p:cNvPr>
@@ -24362,7 +24302,7 @@
           <p:cNvPr id="534" name="">
             <a:extLst xmlns:a="http://schemas.openxmlformats.org/drawingml/2006/main">
               <a:ext uri="{FF2B5EF4-FFF2-40B4-BE49-F238E27FC236}">
-                <a16:creationId xmlns:a16="http://schemas.microsoft.com/office/drawing/2014/main" id="{7FC1DEDF-585D-41F2-AA34-8ABC66ED81A5}"/>
+                <a16:creationId xmlns:a16="http://schemas.microsoft.com/office/drawing/2014/main" id="{354148E4-91DD-4091-9755-846CBD5FC793}"/>
               </a:ext>
             </a:extLst>
           </p:cNvPr>
@@ -24722,7 +24662,7 @@
           <p:cNvPr id="535" name="Takeaway">
             <a:extLst xmlns:a="http://schemas.openxmlformats.org/drawingml/2006/main">
               <a:ext uri="{FF2B5EF4-FFF2-40B4-BE49-F238E27FC236}">
-                <a16:creationId xmlns:a16="http://schemas.microsoft.com/office/drawing/2014/main" id="{54E91967-B7BE-4B3A-B047-70BC7F5553AB}"/>
+                <a16:creationId xmlns:a16="http://schemas.microsoft.com/office/drawing/2014/main" id="{37164DC2-CFF4-442E-B39A-AACBDA7912AF}"/>
               </a:ext>
             </a:extLst>
           </p:cNvPr>
@@ -26105,7 +26045,7 @@
           <p:cNvPr id="534" name="Takeaway">
             <a:extLst xmlns:a="http://schemas.openxmlformats.org/drawingml/2006/main">
               <a:ext uri="{FF2B5EF4-FFF2-40B4-BE49-F238E27FC236}">
-                <a16:creationId xmlns:a16="http://schemas.microsoft.com/office/drawing/2014/main" id="{D22B5CA5-F49B-4631-A8C4-D1B329AA3E1A}"/>
+                <a16:creationId xmlns:a16="http://schemas.microsoft.com/office/drawing/2014/main" id="{DE634C2C-0898-4853-A5C4-D01918BBB8B2}"/>
               </a:ext>
             </a:extLst>
           </p:cNvPr>
@@ -27472,7 +27412,7 @@
           <p:cNvPr id="534" name="Takeaway">
             <a:extLst xmlns:a="http://schemas.openxmlformats.org/drawingml/2006/main">
               <a:ext uri="{FF2B5EF4-FFF2-40B4-BE49-F238E27FC236}">
-                <a16:creationId xmlns:a16="http://schemas.microsoft.com/office/drawing/2014/main" id="{98DF3F86-688D-41F1-B726-EB7D8937A18C}"/>
+                <a16:creationId xmlns:a16="http://schemas.microsoft.com/office/drawing/2014/main" id="{ED771414-6432-454D-8253-E68F1E8D3552}"/>
               </a:ext>
             </a:extLst>
           </p:cNvPr>
@@ -28723,7 +28663,7 @@
           <p:cNvPr id="534" name="">
             <a:extLst xmlns:a="http://schemas.openxmlformats.org/drawingml/2006/main">
               <a:ext uri="{FF2B5EF4-FFF2-40B4-BE49-F238E27FC236}">
-                <a16:creationId xmlns:a16="http://schemas.microsoft.com/office/drawing/2014/main" id="{A6CA8972-7F91-42B4-AE94-9DA0F1C08D7B}"/>
+                <a16:creationId xmlns:a16="http://schemas.microsoft.com/office/drawing/2014/main" id="{89013C81-78D9-4D92-AF05-E237CFA2DC9F}"/>
               </a:ext>
             </a:extLst>
           </p:cNvPr>
@@ -29724,7 +29664,7 @@
           <p:cNvPr id="535" name="Takeaway">
             <a:extLst xmlns:a="http://schemas.openxmlformats.org/drawingml/2006/main">
               <a:ext uri="{FF2B5EF4-FFF2-40B4-BE49-F238E27FC236}">
-                <a16:creationId xmlns:a16="http://schemas.microsoft.com/office/drawing/2014/main" id="{8EF1B560-B096-42E8-972F-CCA82F71CDC0}"/>
+                <a16:creationId xmlns:a16="http://schemas.microsoft.com/office/drawing/2014/main" id="{80E7B2F5-B15B-4346-B9E1-82DA41827297}"/>
               </a:ext>
             </a:extLst>
           </p:cNvPr>
@@ -31157,7 +31097,7 @@
           <p:cNvPr id="534" name="Takeaway">
             <a:extLst xmlns:a="http://schemas.openxmlformats.org/drawingml/2006/main">
               <a:ext uri="{FF2B5EF4-FFF2-40B4-BE49-F238E27FC236}">
-                <a16:creationId xmlns:a16="http://schemas.microsoft.com/office/drawing/2014/main" id="{F73F9572-35ED-47A8-B89D-E9E414778EB0}"/>
+                <a16:creationId xmlns:a16="http://schemas.microsoft.com/office/drawing/2014/main" id="{ED900BF0-8FCE-4DC5-929A-57620050F0A2}"/>
               </a:ext>
             </a:extLst>
           </p:cNvPr>
@@ -32558,7 +32498,7 @@
           <p:cNvPr id="534" name="Takeaway">
             <a:extLst xmlns:a="http://schemas.openxmlformats.org/drawingml/2006/main">
               <a:ext uri="{FF2B5EF4-FFF2-40B4-BE49-F238E27FC236}">
-                <a16:creationId xmlns:a16="http://schemas.microsoft.com/office/drawing/2014/main" id="{84CC2B02-4776-48FD-BD79-2B43A6FAB43B}"/>
+                <a16:creationId xmlns:a16="http://schemas.microsoft.com/office/drawing/2014/main" id="{93E96C14-84FF-4F4D-B462-2FB25CA11BBD}"/>
               </a:ext>
             </a:extLst>
           </p:cNvPr>
@@ -33974,7 +33914,7 @@
           <p:cNvPr id="534" name="Takeaway">
             <a:extLst xmlns:a="http://schemas.openxmlformats.org/drawingml/2006/main">
               <a:ext uri="{FF2B5EF4-FFF2-40B4-BE49-F238E27FC236}">
-                <a16:creationId xmlns:a16="http://schemas.microsoft.com/office/drawing/2014/main" id="{463D7B2B-D827-4763-BC3E-4162B4F622FC}"/>
+                <a16:creationId xmlns:a16="http://schemas.microsoft.com/office/drawing/2014/main" id="{C6759121-7196-456C-9EED-108C886AEE21}"/>
               </a:ext>
             </a:extLst>
           </p:cNvPr>
@@ -35423,7 +35363,7 @@
           <p:cNvPr id="534" name="Takeaway">
             <a:extLst xmlns:a="http://schemas.openxmlformats.org/drawingml/2006/main">
               <a:ext uri="{FF2B5EF4-FFF2-40B4-BE49-F238E27FC236}">
-                <a16:creationId xmlns:a16="http://schemas.microsoft.com/office/drawing/2014/main" id="{525C13C1-DA6D-430D-BB9B-23AB3BB3159F}"/>
+                <a16:creationId xmlns:a16="http://schemas.microsoft.com/office/drawing/2014/main" id="{7A41ED02-16A2-4943-A9A0-D2FC2D8A4863}"/>
               </a:ext>
             </a:extLst>
           </p:cNvPr>
@@ -36806,7 +36746,7 @@
           <p:cNvPr id="534" name="Takeaway">
             <a:extLst xmlns:a="http://schemas.openxmlformats.org/drawingml/2006/main">
               <a:ext uri="{FF2B5EF4-FFF2-40B4-BE49-F238E27FC236}">
-                <a16:creationId xmlns:a16="http://schemas.microsoft.com/office/drawing/2014/main" id="{E76CB519-6CEB-481C-8A8D-146C80B6DE66}"/>
+                <a16:creationId xmlns:a16="http://schemas.microsoft.com/office/drawing/2014/main" id="{70053DA7-F09D-4570-847F-32397D0C0051}"/>
               </a:ext>
             </a:extLst>
           </p:cNvPr>
@@ -38222,7 +38162,7 @@
           <p:cNvPr id="534" name="Takeaway">
             <a:extLst xmlns:a="http://schemas.openxmlformats.org/drawingml/2006/main">
               <a:ext uri="{FF2B5EF4-FFF2-40B4-BE49-F238E27FC236}">
-                <a16:creationId xmlns:a16="http://schemas.microsoft.com/office/drawing/2014/main" id="{40E38B24-8A66-4F69-8F56-00B8880354A2}"/>
+                <a16:creationId xmlns:a16="http://schemas.microsoft.com/office/drawing/2014/main" id="{B351121F-963A-41AF-9926-D6A656F8F5CE}"/>
               </a:ext>
             </a:extLst>
           </p:cNvPr>
@@ -39639,7 +39579,7 @@
           <p:cNvPr id="534" name="Takeaway">
             <a:extLst xmlns:a="http://schemas.openxmlformats.org/drawingml/2006/main">
               <a:ext uri="{FF2B5EF4-FFF2-40B4-BE49-F238E27FC236}">
-                <a16:creationId xmlns:a16="http://schemas.microsoft.com/office/drawing/2014/main" id="{8327313E-B5A9-414A-9154-BF19113DC5C3}"/>
+                <a16:creationId xmlns:a16="http://schemas.microsoft.com/office/drawing/2014/main" id="{5ED3F4BE-38B6-4980-9309-D1E6087DBA1E}"/>
               </a:ext>
             </a:extLst>
           </p:cNvPr>
@@ -41138,7 +41078,7 @@
           <p:cNvPr id="534" name="Takeaway">
             <a:extLst xmlns:a="http://schemas.openxmlformats.org/drawingml/2006/main">
               <a:ext uri="{FF2B5EF4-FFF2-40B4-BE49-F238E27FC236}">
-                <a16:creationId xmlns:a16="http://schemas.microsoft.com/office/drawing/2014/main" id="{830936F1-E763-42FE-BE05-09C52649B3AA}"/>
+                <a16:creationId xmlns:a16="http://schemas.microsoft.com/office/drawing/2014/main" id="{C4F297A4-0022-447E-B6ED-41A7D723F31A}"/>
               </a:ext>
             </a:extLst>
           </p:cNvPr>

</xml_diff>

<commit_message>
Remove wider-register slide from midterm review
</commit_message>
<xml_diff>
--- a/public/presentations/CS211_Recitation_7.pptx
+++ b/public/presentations/CS211_Recitation_7.pptx
@@ -2,45 +2,44 @@
 <file path=ppt/presentation.xml><?xml version="1.0" encoding="utf-8"?>
 <p:presentation xmlns:p="http://schemas.openxmlformats.org/presentationml/2006/main" embedTrueTypeFonts="1" saveSubsetFonts="0">
   <p:sldMasterIdLst>
-    <p:sldMasterId xmlns:r="http://schemas.openxmlformats.org/officeDocument/2006/relationships" id="2147483648" r:id="R0e7a8a5136224fde"/>
+    <p:sldMasterId xmlns:r="http://schemas.openxmlformats.org/officeDocument/2006/relationships" id="2147483648" r:id="Rce25d4b090c14cc1"/>
   </p:sldMasterIdLst>
   <p:notesMasterIdLst>
-    <p:notesMasterId xmlns:r="http://schemas.openxmlformats.org/officeDocument/2006/relationships" r:id="R30214bec0cbd41fb"/>
+    <p:notesMasterId xmlns:r="http://schemas.openxmlformats.org/officeDocument/2006/relationships" r:id="R3d8ab4d9cfa54910"/>
   </p:notesMasterIdLst>
   <p:sldIdLst>
-    <p:sldId xmlns:r="http://schemas.openxmlformats.org/officeDocument/2006/relationships" id="256" r:id="R54a419f5acf44c12"/>
-    <p:sldId xmlns:r="http://schemas.openxmlformats.org/officeDocument/2006/relationships" id="257" r:id="R49ac621a0d9b4676"/>
-    <p:sldId xmlns:r="http://schemas.openxmlformats.org/officeDocument/2006/relationships" id="258" r:id="Re4472a261d8542e8"/>
-    <p:sldId xmlns:r="http://schemas.openxmlformats.org/officeDocument/2006/relationships" id="259" r:id="R6c5dafd550964940"/>
-    <p:sldId xmlns:r="http://schemas.openxmlformats.org/officeDocument/2006/relationships" id="260" r:id="R0645639e024349e5"/>
-    <p:sldId xmlns:r="http://schemas.openxmlformats.org/officeDocument/2006/relationships" id="261" r:id="Rf8235a4e25294fb2"/>
-    <p:sldId xmlns:r="http://schemas.openxmlformats.org/officeDocument/2006/relationships" id="262" r:id="R3885ed69a77341ef"/>
-    <p:sldId xmlns:r="http://schemas.openxmlformats.org/officeDocument/2006/relationships" id="263" r:id="Rfed9f0f27eaa41a4"/>
-    <p:sldId xmlns:r="http://schemas.openxmlformats.org/officeDocument/2006/relationships" id="264" r:id="Rdb536370759844aa"/>
-    <p:sldId xmlns:r="http://schemas.openxmlformats.org/officeDocument/2006/relationships" id="265" r:id="Rd2500efbb61c4c85"/>
-    <p:sldId xmlns:r="http://schemas.openxmlformats.org/officeDocument/2006/relationships" id="266" r:id="R880313408f394e54"/>
-    <p:sldId xmlns:r="http://schemas.openxmlformats.org/officeDocument/2006/relationships" id="267" r:id="R02b1380f3bb64349"/>
-    <p:sldId xmlns:r="http://schemas.openxmlformats.org/officeDocument/2006/relationships" id="268" r:id="R7c461ae444dd4ab6"/>
-    <p:sldId xmlns:r="http://schemas.openxmlformats.org/officeDocument/2006/relationships" id="269" r:id="Rfa762dbcad7f49e7"/>
-    <p:sldId xmlns:r="http://schemas.openxmlformats.org/officeDocument/2006/relationships" id="270" r:id="R3a98809f153145e8"/>
-    <p:sldId xmlns:r="http://schemas.openxmlformats.org/officeDocument/2006/relationships" id="271" r:id="Rc548e0460ad84b13"/>
-    <p:sldId xmlns:r="http://schemas.openxmlformats.org/officeDocument/2006/relationships" id="272" r:id="Rf64c3155233f4a99"/>
-    <p:sldId xmlns:r="http://schemas.openxmlformats.org/officeDocument/2006/relationships" id="273" r:id="R1eba9e2d8d0a4517"/>
-    <p:sldId xmlns:r="http://schemas.openxmlformats.org/officeDocument/2006/relationships" id="274" r:id="R8a9da1a01da047c9"/>
-    <p:sldId xmlns:r="http://schemas.openxmlformats.org/officeDocument/2006/relationships" id="275" r:id="R8b1bfbc492a54323"/>
-    <p:sldId xmlns:r="http://schemas.openxmlformats.org/officeDocument/2006/relationships" id="276" r:id="Rbdcd86c0088a44ae"/>
-    <p:sldId xmlns:r="http://schemas.openxmlformats.org/officeDocument/2006/relationships" id="277" r:id="R5146a19a60344a08"/>
-    <p:sldId xmlns:r="http://schemas.openxmlformats.org/officeDocument/2006/relationships" id="278" r:id="Rc266c82505b24b05"/>
+    <p:sldId xmlns:r="http://schemas.openxmlformats.org/officeDocument/2006/relationships" id="256" r:id="R8dab3aaf10494ca6"/>
+    <p:sldId xmlns:r="http://schemas.openxmlformats.org/officeDocument/2006/relationships" id="257" r:id="R7d5ccc01832541e8"/>
+    <p:sldId xmlns:r="http://schemas.openxmlformats.org/officeDocument/2006/relationships" id="258" r:id="Rdf206e1b5c68413b"/>
+    <p:sldId xmlns:r="http://schemas.openxmlformats.org/officeDocument/2006/relationships" id="259" r:id="Rc6a9ea1ad4234004"/>
+    <p:sldId xmlns:r="http://schemas.openxmlformats.org/officeDocument/2006/relationships" id="260" r:id="R213f2f324d604ecf"/>
+    <p:sldId xmlns:r="http://schemas.openxmlformats.org/officeDocument/2006/relationships" id="261" r:id="R994f085237324869"/>
+    <p:sldId xmlns:r="http://schemas.openxmlformats.org/officeDocument/2006/relationships" id="262" r:id="Rb547301698ae4e18"/>
+    <p:sldId xmlns:r="http://schemas.openxmlformats.org/officeDocument/2006/relationships" id="263" r:id="Rf4491fe6e9824604"/>
+    <p:sldId xmlns:r="http://schemas.openxmlformats.org/officeDocument/2006/relationships" id="264" r:id="R4aaa9c64e6b64cf5"/>
+    <p:sldId xmlns:r="http://schemas.openxmlformats.org/officeDocument/2006/relationships" id="265" r:id="R237a5bce76e04972"/>
+    <p:sldId xmlns:r="http://schemas.openxmlformats.org/officeDocument/2006/relationships" id="266" r:id="R23e43d821d4c46c4"/>
+    <p:sldId xmlns:r="http://schemas.openxmlformats.org/officeDocument/2006/relationships" id="267" r:id="R22cfc8b47f234451"/>
+    <p:sldId xmlns:r="http://schemas.openxmlformats.org/officeDocument/2006/relationships" id="268" r:id="Rad941524ed7249c8"/>
+    <p:sldId xmlns:r="http://schemas.openxmlformats.org/officeDocument/2006/relationships" id="269" r:id="Rfa68cad13ed94f25"/>
+    <p:sldId xmlns:r="http://schemas.openxmlformats.org/officeDocument/2006/relationships" id="270" r:id="R83f8a8dcc0b940c2"/>
+    <p:sldId xmlns:r="http://schemas.openxmlformats.org/officeDocument/2006/relationships" id="271" r:id="Ra1f85339196c45e5"/>
+    <p:sldId xmlns:r="http://schemas.openxmlformats.org/officeDocument/2006/relationships" id="272" r:id="R80d8b52298e4429a"/>
+    <p:sldId xmlns:r="http://schemas.openxmlformats.org/officeDocument/2006/relationships" id="273" r:id="R648563cf5ac0469a"/>
+    <p:sldId xmlns:r="http://schemas.openxmlformats.org/officeDocument/2006/relationships" id="274" r:id="R1484e7ecbec949d8"/>
+    <p:sldId xmlns:r="http://schemas.openxmlformats.org/officeDocument/2006/relationships" id="275" r:id="Rb79833eaa2df4063"/>
+    <p:sldId xmlns:r="http://schemas.openxmlformats.org/officeDocument/2006/relationships" id="276" r:id="R1e45ea9a4fc241b8"/>
+    <p:sldId xmlns:r="http://schemas.openxmlformats.org/officeDocument/2006/relationships" id="277" r:id="R023748979ad74fa2"/>
   </p:sldIdLst>
   <p:sldSz cx="12192000" cy="6858000"/>
   <p:notesSz cx="6858000" cy="9144000"/>
   <p:embeddedFontLst>
     <p:embeddedFont>
       <p:font typeface="OpenAI Sans"/>
-      <p:regular xmlns:r="http://schemas.openxmlformats.org/officeDocument/2006/relationships" r:id="Rc93f8612a50a40d7"/>
-      <p:bold xmlns:r="http://schemas.openxmlformats.org/officeDocument/2006/relationships" r:id="R7bcd55f6e24d44e8"/>
-      <p:italic xmlns:r="http://schemas.openxmlformats.org/officeDocument/2006/relationships" r:id="R04d937ebf9d84e42"/>
-      <p:boldItalic xmlns:r="http://schemas.openxmlformats.org/officeDocument/2006/relationships" r:id="Rebc70526097844a6"/>
+      <p:regular xmlns:r="http://schemas.openxmlformats.org/officeDocument/2006/relationships" r:id="R28d6267d361b48d6"/>
+      <p:bold xmlns:r="http://schemas.openxmlformats.org/officeDocument/2006/relationships" r:id="Ra8af04b54b4345d6"/>
+      <p:italic xmlns:r="http://schemas.openxmlformats.org/officeDocument/2006/relationships" r:id="R4960771da5a049cf"/>
+      <p:boldItalic xmlns:r="http://schemas.openxmlformats.org/officeDocument/2006/relationships" r:id="Rb2e071fd818540bd"/>
     </p:embeddedFont>
   </p:embeddedFontLst>
   <p:defaultTextStyle>
@@ -1942,7 +1941,7 @@
               <a:buNone/>
             </a:pPr>
             <a:r>
-              <a:t>Say: a large tray can hold one small cup; tray size and cup size are different. This is why both 64-bit and 8-byte choices on released Quiz 3A Q11 were insufficient. XMM is the low 128 bits of the corresponding YMM; ZMM, when present, extends that storage further. x87 has its own register stack, separate from the function-call stack. MMX registers are packed-integer aliases of x87 storage, not another name for XMM. Scalar mulss/addss use float values, not integer addition of their bit encodings.</a:t>
+              <a:t>Ask the two answer-reveal questions aloud: convert 0xA7; then list bytes of 0xA7B2 little-endian. Break into 4-bit groups and insist on preserving leading zeros within each nibble. For the endian example, draw addresses 1000 and 1001 and place full byte pairs into them. Do not reverse the digits inside a byte or the individual bits. Reading a uint32_t word in GDB and listing its bytes are different displays.</a:t>
             </a:r>
             <a:endParaRPr/>
           </a:p>
@@ -1972,7 +1971,7 @@
               <a:buNone/>
             </a:pPr>
             <a:r>
-              <a:t>Sources: https://firner.com/presentations/cs211/2026-Fall/cs211_11/; https://www.intel.com/content/www/us/en/developer/articles/technical/intel-sdm.html</a:t>
+              <a:t>Sources: https://firner.com/presentations/cs211/2026-Fall/cs211_01/; https://firner.com/presentations/cs211/2026-Fall/cs211_03/</a:t>
             </a:r>
             <a:endParaRPr/>
           </a:p>
@@ -2002,7 +2001,7 @@
               <a:buNone/>
             </a:pPr>
             <a:r>
-              <a:t>Answer: 1. A 32-bit float stored in XMM does not make XMM a 32-bit register. XMM is 128 bits wide.</a:t>
+              <a:t>Answer: 1. 0xA7 expands to 1010 0111₂.</a:t>
             </a:r>
             <a:endParaRPr/>
           </a:p>
@@ -2032,7 +2031,7 @@
               <a:buNone/>
             </a:pPr>
             <a:r>
-              <a:t>2. The largest available register depends on CPU extensions; common examples are wider than 64 bits.</a:t>
+              <a:t>2. In little-endian memory, 0xA7B2 as a 16-bit value stores B2 first, then A7.</a:t>
             </a:r>
             <a:endParaRPr/>
           </a:p>
@@ -2112,7 +2111,7 @@
               <a:buNone/>
             </a:pPr>
             <a:r>
-              <a:t>Ask the two answer-reveal questions aloud: convert 0xA7; then list bytes of 0xA7B2 little-endian. Break into 4-bit groups and insist on preserving leading zeros within each nibble. For the endian example, draw addresses 1000 and 1001 and place full byte pairs into them. Do not reverse the digits inside a byte or the individual bits. Reading a uint32_t word in GDB and listing its bytes are different displays.</a:t>
+              <a:t>Emphasize interpretation rather than a separate collection of signed memory cells. For general n-bit signed values, minimum is −2^(n−1) and maximum is 2^(n−1)−1. This is a fixed-width hardware/representation exercise. In C, small integer types are usually promoted before arithmetic, and signed overflow at the operation’s actual type width is undefined behavior; do not claim ordinary signed C overflow is guaranteed to wrap.</a:t>
             </a:r>
             <a:endParaRPr/>
           </a:p>
@@ -2142,7 +2141,7 @@
               <a:buNone/>
             </a:pPr>
             <a:r>
-              <a:t>Sources: https://firner.com/presentations/cs211/2026-Fall/cs211_01/; https://firner.com/presentations/cs211/2026-Fall/cs211_03/</a:t>
+              <a:t>Sources: https://firner.com/presentations/cs211/2026-Fall/cs211_02/; https://firner.com/presentations/cs211/2026-Fall/cs211_04/</a:t>
             </a:r>
             <a:endParaRPr/>
           </a:p>
@@ -2172,7 +2171,7 @@
               <a:buNone/>
             </a:pPr>
             <a:r>
-              <a:t>Answer: 1. 0xA7 expands to 1010 0111₂.</a:t>
+              <a:t>Answer: 1. Signed and unsigned 8-bit values each have 256 possible patterns.</a:t>
             </a:r>
             <a:endParaRPr/>
           </a:p>
@@ -2202,7 +2201,7 @@
               <a:buNone/>
             </a:pPr>
             <a:r>
-              <a:t>2. In little-endian memory, 0xA7B2 as a 16-bit value stores B2 first, then A7.</a:t>
+              <a:t>2. The fixed-width negation pattern for 10000000 is still 10000000. Read as signed, it is −128, but the desired positive result overflowed the signed 8-bit range.</a:t>
             </a:r>
             <a:endParaRPr/>
           </a:p>
@@ -2482,7 +2481,7 @@
               <a:buNone/>
             </a:pPr>
             <a:r>
-              <a:t>Emphasize interpretation rather than a separate collection of signed memory cells. For general n-bit signed values, minimum is −2^(n−1) and maximum is 2^(n−1)−1. This is a fixed-width hardware/representation exercise. In C, small integer types are usually promoted before arithmetic, and signed overflow at the operation’s actual type width is undefined behavior; do not claim ordinary signed C overflow is guaranteed to wrap.</a:t>
+              <a:t>Draw eight seats in a row; a shift throws the person at the end away, while a rotation sends that person around to the empty seat. For the homework-style method, combine a masked left shift with x &gt;&gt; 7. State the width and use unsigned arithmetic; shift counts must be valid for the promoted operand type. This is a one-bit illustration, not a complete general rotation function with all edge cases.</a:t>
             </a:r>
             <a:endParaRPr/>
           </a:p>
@@ -2512,7 +2511,7 @@
               <a:buNone/>
             </a:pPr>
             <a:r>
-              <a:t>Sources: https://firner.com/presentations/cs211/2026-Fall/cs211_02/; https://firner.com/presentations/cs211/2026-Fall/cs211_04/</a:t>
+              <a:t>Sources: https://firner.com/presentations/cs211/2026-Fall/cs211_02/; https://firner.com/presentations/cs211/2026-Fall/hw2.html</a:t>
             </a:r>
             <a:endParaRPr/>
           </a:p>
@@ -2542,7 +2541,7 @@
               <a:buNone/>
             </a:pPr>
             <a:r>
-              <a:t>Answer: 1. Signed and unsigned 8-bit values each have 256 possible patterns.</a:t>
+              <a:t>Answer: 1. x &amp; 0x0F = 0x06, keeping the low four bits.</a:t>
             </a:r>
             <a:endParaRPr/>
           </a:p>
@@ -2572,7 +2571,37 @@
               <a:buNone/>
             </a:pPr>
             <a:r>
-              <a:t>2. The fixed-width negation pattern for 10000000 is still 10000000. Read as signed, it is −128, but the desired positive result overflowed the signed 8-bit range.</a:t>
+              <a:t>2. The masked left shift is 0x6C = 01101100₂.</a:t>
+            </a:r>
+            <a:endParaRPr/>
+          </a:p>
+          <a:p xmlns:a="http://schemas.openxmlformats.org/drawingml/2006/main">
+            <a:pPr marL="0" lvl="0" indent="0" algn="l">
+              <a:spcBef>
+                <a:spcPts val="0"/>
+              </a:spcBef>
+              <a:spcAft>
+                <a:spcPts val="0"/>
+              </a:spcAft>
+              <a:buNone/>
+            </a:pPr>
+            <a:r>
+              <a:t/>
+            </a:r>
+            <a:endParaRPr/>
+          </a:p>
+          <a:p xmlns:a="http://schemas.openxmlformats.org/drawingml/2006/main">
+            <a:pPr marL="0" lvl="0" indent="0" algn="l">
+              <a:spcBef>
+                <a:spcPts val="0"/>
+              </a:spcBef>
+              <a:spcAft>
+                <a:spcPts val="0"/>
+              </a:spcAft>
+              <a:buNone/>
+            </a:pPr>
+            <a:r>
+              <a:t>3. The rotation is 0x6D = 01101101₂: the old top bit becomes the low bit.</a:t>
             </a:r>
             <a:endParaRPr/>
           </a:p>
@@ -2652,7 +2681,7 @@
               <a:buNone/>
             </a:pPr>
             <a:r>
-              <a:t>Draw eight seats in a row; a shift throws the person at the end away, while a rotation sends that person around to the empty seat. For the homework-style method, combine a masked left shift with x &gt;&gt; 7. State the width and use unsigned arithmetic; shift counts must be valid for the promoted operand type. This is a one-bit illustration, not a complete general rotation function with all edge cases.</a:t>
+              <a:t>Board: draw columns A, B, A AND B, NOT A, Out. For each row, fill both internal columns before Out. Circle the wire entering NOT so students do not invert the wrong input. In C, bitwise &amp;, |, ~ operate on bit patterns, while logical &amp;&amp;, ||, ! operate on truth values; this slide is single-bit logic. A truth table with n binary inputs needs 2^n rows.</a:t>
             </a:r>
             <a:endParaRPr/>
           </a:p>
@@ -2682,7 +2711,7 @@
               <a:buNone/>
             </a:pPr>
             <a:r>
-              <a:t>Sources: https://firner.com/presentations/cs211/2026-Fall/cs211_02/; https://firner.com/presentations/cs211/2026-Fall/hw2.html</a:t>
+              <a:t>Sources: https://firner.com/presentations/cs211/2026-Fall/cs211_02/; https://firner.com/presentations/cs211/2026-Fall/cs211_12/</a:t>
             </a:r>
             <a:endParaRPr/>
           </a:p>
@@ -2712,7 +2741,7 @@
               <a:buNone/>
             </a:pPr>
             <a:r>
-              <a:t>Answer: 1. x &amp; 0x0F = 0x06, keeping the low four bits.</a:t>
+              <a:t>Answer: 1. A=0,B=0: AND=0, NOT A=1, so output=1.</a:t>
             </a:r>
             <a:endParaRPr/>
           </a:p>
@@ -2742,7 +2771,7 @@
               <a:buNone/>
             </a:pPr>
             <a:r>
-              <a:t>2. The masked left shift is 0x6C = 01101100₂.</a:t>
+              <a:t>2. A=0,B=1: AND=0, NOT A=1, so output=1.</a:t>
             </a:r>
             <a:endParaRPr/>
           </a:p>
@@ -2772,7 +2801,37 @@
               <a:buNone/>
             </a:pPr>
             <a:r>
-              <a:t>3. The rotation is 0x6D = 01101101₂: the old top bit becomes the low bit.</a:t>
+              <a:t>3. A=1,B=0: AND=0, NOT A=0, so output=0.</a:t>
+            </a:r>
+            <a:endParaRPr/>
+          </a:p>
+          <a:p xmlns:a="http://schemas.openxmlformats.org/drawingml/2006/main">
+            <a:pPr marL="0" lvl="0" indent="0" algn="l">
+              <a:spcBef>
+                <a:spcPts val="0"/>
+              </a:spcBef>
+              <a:spcAft>
+                <a:spcPts val="0"/>
+              </a:spcAft>
+              <a:buNone/>
+            </a:pPr>
+            <a:r>
+              <a:t/>
+            </a:r>
+            <a:endParaRPr/>
+          </a:p>
+          <a:p xmlns:a="http://schemas.openxmlformats.org/drawingml/2006/main">
+            <a:pPr marL="0" lvl="0" indent="0" algn="l">
+              <a:spcBef>
+                <a:spcPts val="0"/>
+              </a:spcBef>
+              <a:spcAft>
+                <a:spcPts val="0"/>
+              </a:spcAft>
+              <a:buNone/>
+            </a:pPr>
+            <a:r>
+              <a:t>4. A=1,B=1: AND=1, NOT A=0, so output=1.</a:t>
             </a:r>
             <a:endParaRPr/>
           </a:p>
@@ -2804,236 +2863,6 @@
 </file>
 
 <file path=ppt/notesSlides/notesSlide22.xml><?xml version="1.0" encoding="utf-8"?>
-<p:notes xmlns:p="http://schemas.openxmlformats.org/presentationml/2006/main">
-  <p:cSld>
-    <p:spTree>
-      <p:nvGrpSpPr>
-        <p:cNvPr id="1" name=""/>
-        <p:cNvGrpSpPr/>
-        <p:nvPr/>
-      </p:nvGrpSpPr>
-      <p:grpSpPr>
-        <a:xfrm xmlns:a="http://schemas.openxmlformats.org/drawingml/2006/main"/>
-      </p:grpSpPr>
-      <p:sp>
-        <p:nvSpPr>
-          <p:cNvPr id="2" name="Slide Image Placeholder 1"/>
-          <p:cNvSpPr>
-            <a:spLocks xmlns:a="http://schemas.openxmlformats.org/drawingml/2006/main" noGrp="1"/>
-          </p:cNvSpPr>
-          <p:nvPr>
-            <p:ph type="sldImg" idx="0"/>
-          </p:nvPr>
-        </p:nvSpPr>
-        <p:spPr/>
-      </p:sp>
-      <p:sp>
-        <p:nvSpPr>
-          <p:cNvPr id="3" name="Notes Placeholder 2"/>
-          <p:cNvSpPr>
-            <a:spLocks xmlns:a="http://schemas.openxmlformats.org/drawingml/2006/main" noGrp="1"/>
-          </p:cNvSpPr>
-          <p:nvPr>
-            <p:ph type="body" idx="1"/>
-          </p:nvPr>
-        </p:nvSpPr>
-        <p:spPr/>
-        <p:txBody>
-          <a:bodyPr xmlns:a="http://schemas.openxmlformats.org/drawingml/2006/main"/>
-          <a:lstStyle xmlns:a="http://schemas.openxmlformats.org/drawingml/2006/main"/>
-          <a:p xmlns:a="http://schemas.openxmlformats.org/drawingml/2006/main">
-            <a:pPr marL="0" lvl="0" indent="0" algn="l">
-              <a:spcBef>
-                <a:spcPts val="0"/>
-              </a:spcBef>
-              <a:spcAft>
-                <a:spcPts val="0"/>
-              </a:spcAft>
-              <a:buNone/>
-            </a:pPr>
-            <a:r>
-              <a:t>Board: draw columns A, B, A AND B, NOT A, Out. For each row, fill both internal columns before Out. Circle the wire entering NOT so students do not invert the wrong input. In C, bitwise &amp;, |, ~ operate on bit patterns, while logical &amp;&amp;, ||, ! operate on truth values; this slide is single-bit logic. A truth table with n binary inputs needs 2^n rows.</a:t>
-            </a:r>
-            <a:endParaRPr/>
-          </a:p>
-          <a:p xmlns:a="http://schemas.openxmlformats.org/drawingml/2006/main">
-            <a:pPr marL="0" lvl="0" indent="0" algn="l">
-              <a:spcBef>
-                <a:spcPts val="0"/>
-              </a:spcBef>
-              <a:spcAft>
-                <a:spcPts val="0"/>
-              </a:spcAft>
-              <a:buNone/>
-            </a:pPr>
-            <a:r>
-              <a:t/>
-            </a:r>
-            <a:endParaRPr/>
-          </a:p>
-          <a:p xmlns:a="http://schemas.openxmlformats.org/drawingml/2006/main">
-            <a:pPr marL="0" lvl="0" indent="0" algn="l">
-              <a:spcBef>
-                <a:spcPts val="0"/>
-              </a:spcBef>
-              <a:spcAft>
-                <a:spcPts val="0"/>
-              </a:spcAft>
-              <a:buNone/>
-            </a:pPr>
-            <a:r>
-              <a:t>Sources: https://firner.com/presentations/cs211/2026-Fall/cs211_02/; https://firner.com/presentations/cs211/2026-Fall/cs211_12/</a:t>
-            </a:r>
-            <a:endParaRPr/>
-          </a:p>
-          <a:p xmlns:a="http://schemas.openxmlformats.org/drawingml/2006/main">
-            <a:pPr marL="0" lvl="0" indent="0" algn="l">
-              <a:spcBef>
-                <a:spcPts val="0"/>
-              </a:spcBef>
-              <a:spcAft>
-                <a:spcPts val="0"/>
-              </a:spcAft>
-              <a:buNone/>
-            </a:pPr>
-            <a:r>
-              <a:t/>
-            </a:r>
-            <a:endParaRPr/>
-          </a:p>
-          <a:p xmlns:a="http://schemas.openxmlformats.org/drawingml/2006/main">
-            <a:pPr marL="0" lvl="0" indent="0" algn="l">
-              <a:spcBef>
-                <a:spcPts val="0"/>
-              </a:spcBef>
-              <a:spcAft>
-                <a:spcPts val="0"/>
-              </a:spcAft>
-              <a:buNone/>
-            </a:pPr>
-            <a:r>
-              <a:t>Answer: 1. A=0,B=0: AND=0, NOT A=1, so output=1.</a:t>
-            </a:r>
-            <a:endParaRPr/>
-          </a:p>
-          <a:p xmlns:a="http://schemas.openxmlformats.org/drawingml/2006/main">
-            <a:pPr marL="0" lvl="0" indent="0" algn="l">
-              <a:spcBef>
-                <a:spcPts val="0"/>
-              </a:spcBef>
-              <a:spcAft>
-                <a:spcPts val="0"/>
-              </a:spcAft>
-              <a:buNone/>
-            </a:pPr>
-            <a:r>
-              <a:t/>
-            </a:r>
-            <a:endParaRPr/>
-          </a:p>
-          <a:p xmlns:a="http://schemas.openxmlformats.org/drawingml/2006/main">
-            <a:pPr marL="0" lvl="0" indent="0" algn="l">
-              <a:spcBef>
-                <a:spcPts val="0"/>
-              </a:spcBef>
-              <a:spcAft>
-                <a:spcPts val="0"/>
-              </a:spcAft>
-              <a:buNone/>
-            </a:pPr>
-            <a:r>
-              <a:t>2. A=0,B=1: AND=0, NOT A=1, so output=1.</a:t>
-            </a:r>
-            <a:endParaRPr/>
-          </a:p>
-          <a:p xmlns:a="http://schemas.openxmlformats.org/drawingml/2006/main">
-            <a:pPr marL="0" lvl="0" indent="0" algn="l">
-              <a:spcBef>
-                <a:spcPts val="0"/>
-              </a:spcBef>
-              <a:spcAft>
-                <a:spcPts val="0"/>
-              </a:spcAft>
-              <a:buNone/>
-            </a:pPr>
-            <a:r>
-              <a:t/>
-            </a:r>
-            <a:endParaRPr/>
-          </a:p>
-          <a:p xmlns:a="http://schemas.openxmlformats.org/drawingml/2006/main">
-            <a:pPr marL="0" lvl="0" indent="0" algn="l">
-              <a:spcBef>
-                <a:spcPts val="0"/>
-              </a:spcBef>
-              <a:spcAft>
-                <a:spcPts val="0"/>
-              </a:spcAft>
-              <a:buNone/>
-            </a:pPr>
-            <a:r>
-              <a:t>3. A=1,B=0: AND=0, NOT A=0, so output=0.</a:t>
-            </a:r>
-            <a:endParaRPr/>
-          </a:p>
-          <a:p xmlns:a="http://schemas.openxmlformats.org/drawingml/2006/main">
-            <a:pPr marL="0" lvl="0" indent="0" algn="l">
-              <a:spcBef>
-                <a:spcPts val="0"/>
-              </a:spcBef>
-              <a:spcAft>
-                <a:spcPts val="0"/>
-              </a:spcAft>
-              <a:buNone/>
-            </a:pPr>
-            <a:r>
-              <a:t/>
-            </a:r>
-            <a:endParaRPr/>
-          </a:p>
-          <a:p xmlns:a="http://schemas.openxmlformats.org/drawingml/2006/main">
-            <a:pPr marL="0" lvl="0" indent="0" algn="l">
-              <a:spcBef>
-                <a:spcPts val="0"/>
-              </a:spcBef>
-              <a:spcAft>
-                <a:spcPts val="0"/>
-              </a:spcAft>
-              <a:buNone/>
-            </a:pPr>
-            <a:r>
-              <a:t>4. A=1,B=1: AND=1, NOT A=0, so output=1.</a:t>
-            </a:r>
-            <a:endParaRPr/>
-          </a:p>
-        </p:txBody>
-      </p:sp>
-      <p:sp>
-        <p:nvSpPr>
-          <p:cNvPr id="4" name="Slide Number Placeholder 3"/>
-          <p:cNvSpPr>
-            <a:spLocks xmlns:a="http://schemas.openxmlformats.org/drawingml/2006/main" noGrp="1"/>
-          </p:cNvSpPr>
-          <p:nvPr>
-            <p:ph type="sldNum" idx="5"/>
-          </p:nvPr>
-        </p:nvSpPr>
-        <p:spPr/>
-        <p:txBody>
-          <a:bodyPr xmlns:a="http://schemas.openxmlformats.org/drawingml/2006/main"/>
-          <a:lstStyle xmlns:a="http://schemas.openxmlformats.org/drawingml/2006/main"/>
-          <a:p xmlns:a="http://schemas.openxmlformats.org/drawingml/2006/main"/>
-        </p:txBody>
-      </p:sp>
-    </p:spTree>
-  </p:cSld>
-  <p:clrMapOvr>
-    <a:masterClrMapping xmlns:a="http://schemas.openxmlformats.org/drawingml/2006/main"/>
-  </p:clrMapOvr>
-</p:notes>
-</file>
-
-<file path=ppt/notesSlides/notesSlide23.xml><?xml version="1.0" encoding="utf-8"?>
 <p:notes xmlns:p="http://schemas.openxmlformats.org/presentationml/2006/main">
   <p:cSld>
     <p:spTree>
@@ -6156,14 +5985,14 @@
   </p:cSld>
   <p:clrMap bg1="dk1" tx1="lt1" bg2="dk2" tx2="lt2" accent1="accent1" accent2="accent2" accent3="accent3" accent4="accent4" accent5="accent5" accent6="accent6" hlink="hlink" folHlink="folHlink"/>
   <p:sldLayoutIdLst>
-    <p:sldLayoutId xmlns:r="http://schemas.openxmlformats.org/officeDocument/2006/relationships" id="2147483649" r:id="R78d557211e4b4205"/>
-    <p:sldLayoutId xmlns:r="http://schemas.openxmlformats.org/officeDocument/2006/relationships" id="2147483650" r:id="R04fbee4d4c464775"/>
-    <p:sldLayoutId xmlns:r="http://schemas.openxmlformats.org/officeDocument/2006/relationships" id="2147483651" r:id="R75667768e0084791"/>
-    <p:sldLayoutId xmlns:r="http://schemas.openxmlformats.org/officeDocument/2006/relationships" id="2147483652" r:id="Re451ec1b75de41e1"/>
-    <p:sldLayoutId xmlns:r="http://schemas.openxmlformats.org/officeDocument/2006/relationships" id="2147483653" r:id="Re0d369c2f161460c"/>
-    <p:sldLayoutId xmlns:r="http://schemas.openxmlformats.org/officeDocument/2006/relationships" id="2147483654" r:id="R57b2f11281744806"/>
-    <p:sldLayoutId xmlns:r="http://schemas.openxmlformats.org/officeDocument/2006/relationships" id="2147483655" r:id="R10f7d0a00fee4c25"/>
-    <p:sldLayoutId xmlns:r="http://schemas.openxmlformats.org/officeDocument/2006/relationships" id="2147483656" r:id="R79d3cea4952e4313"/>
+    <p:sldLayoutId xmlns:r="http://schemas.openxmlformats.org/officeDocument/2006/relationships" id="2147483649" r:id="R29f3c32ccf024bba"/>
+    <p:sldLayoutId xmlns:r="http://schemas.openxmlformats.org/officeDocument/2006/relationships" id="2147483650" r:id="Rfe82a67123524ec7"/>
+    <p:sldLayoutId xmlns:r="http://schemas.openxmlformats.org/officeDocument/2006/relationships" id="2147483651" r:id="R764a44180c664fa7"/>
+    <p:sldLayoutId xmlns:r="http://schemas.openxmlformats.org/officeDocument/2006/relationships" id="2147483652" r:id="R5bbc885e11784e98"/>
+    <p:sldLayoutId xmlns:r="http://schemas.openxmlformats.org/officeDocument/2006/relationships" id="2147483653" r:id="R58f791987a7247e7"/>
+    <p:sldLayoutId xmlns:r="http://schemas.openxmlformats.org/officeDocument/2006/relationships" id="2147483654" r:id="R481cb4a3e68b4ea9"/>
+    <p:sldLayoutId xmlns:r="http://schemas.openxmlformats.org/officeDocument/2006/relationships" id="2147483655" r:id="Rd983b1f2b0cf4bce"/>
+    <p:sldLayoutId xmlns:r="http://schemas.openxmlformats.org/officeDocument/2006/relationships" id="2147483656" r:id="Rdd0664d47146485b"/>
   </p:sldLayoutIdLst>
   <p:hf hdr="0" dt="0"/>
   <p:txStyles>
@@ -9034,7 +8863,7 @@
           <p:cNvPr id="534" name="">
             <a:extLst xmlns:a="http://schemas.openxmlformats.org/drawingml/2006/main">
               <a:ext uri="{FF2B5EF4-FFF2-40B4-BE49-F238E27FC236}">
-                <a16:creationId xmlns:a16="http://schemas.microsoft.com/office/drawing/2014/main" id="{971C40B4-20AC-4450-9A51-A85F453F177B}"/>
+                <a16:creationId xmlns:a16="http://schemas.microsoft.com/office/drawing/2014/main" id="{6126DCBC-E03C-4869-9646-67257DF6F56D}"/>
               </a:ext>
             </a:extLst>
           </p:cNvPr>
@@ -9777,7 +9606,7 @@
           <p:cNvPr id="535" name="Takeaway">
             <a:extLst xmlns:a="http://schemas.openxmlformats.org/drawingml/2006/main">
               <a:ext uri="{FF2B5EF4-FFF2-40B4-BE49-F238E27FC236}">
-                <a16:creationId xmlns:a16="http://schemas.microsoft.com/office/drawing/2014/main" id="{7FBE8C99-2F84-48F5-B843-49889E06CF14}"/>
+                <a16:creationId xmlns:a16="http://schemas.microsoft.com/office/drawing/2014/main" id="{D1443A28-0C27-40CF-8121-EF986138E0D3}"/>
               </a:ext>
             </a:extLst>
           </p:cNvPr>
@@ -11161,7 +10990,7 @@
           <p:cNvPr id="534" name="Takeaway">
             <a:extLst xmlns:a="http://schemas.openxmlformats.org/drawingml/2006/main">
               <a:ext uri="{FF2B5EF4-FFF2-40B4-BE49-F238E27FC236}">
-                <a16:creationId xmlns:a16="http://schemas.microsoft.com/office/drawing/2014/main" id="{832D1CA6-F714-43F2-92AB-193FEC35CE41}"/>
+                <a16:creationId xmlns:a16="http://schemas.microsoft.com/office/drawing/2014/main" id="{DC661101-C783-4BC7-AA3B-EE8733ED038C}"/>
               </a:ext>
             </a:extLst>
           </p:cNvPr>
@@ -12594,7 +12423,7 @@
           <p:cNvPr id="534" name="Takeaway">
             <a:extLst xmlns:a="http://schemas.openxmlformats.org/drawingml/2006/main">
               <a:ext uri="{FF2B5EF4-FFF2-40B4-BE49-F238E27FC236}">
-                <a16:creationId xmlns:a16="http://schemas.microsoft.com/office/drawing/2014/main" id="{B9374ABE-FFE3-48BB-BE72-8E7E710AE770}"/>
+                <a16:creationId xmlns:a16="http://schemas.microsoft.com/office/drawing/2014/main" id="{C807CC87-FE4E-45BF-907B-82A3C480A950}"/>
               </a:ext>
             </a:extLst>
           </p:cNvPr>
@@ -14076,7 +13905,7 @@
           <p:cNvPr id="534" name="Takeaway">
             <a:extLst xmlns:a="http://schemas.openxmlformats.org/drawingml/2006/main">
               <a:ext uri="{FF2B5EF4-FFF2-40B4-BE49-F238E27FC236}">
-                <a16:creationId xmlns:a16="http://schemas.microsoft.com/office/drawing/2014/main" id="{0185E7EE-2D1D-45DF-8068-D2D525BD8030}"/>
+                <a16:creationId xmlns:a16="http://schemas.microsoft.com/office/drawing/2014/main" id="{7F882D58-6104-4A81-A780-76E8F7C406FE}"/>
               </a:ext>
             </a:extLst>
           </p:cNvPr>
@@ -15459,7 +15288,7 @@
           <p:cNvPr id="534" name="">
             <a:extLst xmlns:a="http://schemas.openxmlformats.org/drawingml/2006/main">
               <a:ext uri="{FF2B5EF4-FFF2-40B4-BE49-F238E27FC236}">
-                <a16:creationId xmlns:a16="http://schemas.microsoft.com/office/drawing/2014/main" id="{FB8DB4C9-6933-4726-8D17-04EFE20708EA}"/>
+                <a16:creationId xmlns:a16="http://schemas.microsoft.com/office/drawing/2014/main" id="{C3FDB7B7-EF09-4638-BC1D-A97AFF6EBD36}"/>
               </a:ext>
             </a:extLst>
           </p:cNvPr>
@@ -15819,7 +15648,7 @@
           <p:cNvPr id="535" name="Takeaway">
             <a:extLst xmlns:a="http://schemas.openxmlformats.org/drawingml/2006/main">
               <a:ext uri="{FF2B5EF4-FFF2-40B4-BE49-F238E27FC236}">
-                <a16:creationId xmlns:a16="http://schemas.microsoft.com/office/drawing/2014/main" id="{E4C585EB-FCC5-4710-B805-C0B40B32A791}"/>
+                <a16:creationId xmlns:a16="http://schemas.microsoft.com/office/drawing/2014/main" id="{26446728-EABA-4E14-8CD8-CED6FC6ABE33}"/>
               </a:ext>
             </a:extLst>
           </p:cNvPr>
@@ -17269,7 +17098,7 @@
           <p:cNvPr id="534" name="Takeaway">
             <a:extLst xmlns:a="http://schemas.openxmlformats.org/drawingml/2006/main">
               <a:ext uri="{FF2B5EF4-FFF2-40B4-BE49-F238E27FC236}">
-                <a16:creationId xmlns:a16="http://schemas.microsoft.com/office/drawing/2014/main" id="{6742AE34-50CA-4D0F-A8FB-A294D37CF768}"/>
+                <a16:creationId xmlns:a16="http://schemas.microsoft.com/office/drawing/2014/main" id="{8F629B4C-85BF-4BCD-808E-A4824DFE98BF}"/>
               </a:ext>
             </a:extLst>
           </p:cNvPr>
@@ -18669,7 +18498,7 @@
           <p:cNvPr id="534" name="Takeaway">
             <a:extLst xmlns:a="http://schemas.openxmlformats.org/drawingml/2006/main">
               <a:ext uri="{FF2B5EF4-FFF2-40B4-BE49-F238E27FC236}">
-                <a16:creationId xmlns:a16="http://schemas.microsoft.com/office/drawing/2014/main" id="{F5C7BD72-255F-4EBC-AE26-AF106DC0323D}"/>
+                <a16:creationId xmlns:a16="http://schemas.microsoft.com/office/drawing/2014/main" id="{B80853D7-6010-461D-BCF0-B69BAF7757FE}"/>
               </a:ext>
             </a:extLst>
           </p:cNvPr>
@@ -20119,7 +19948,7 @@
           <p:cNvPr id="534" name="Takeaway">
             <a:extLst xmlns:a="http://schemas.openxmlformats.org/drawingml/2006/main">
               <a:ext uri="{FF2B5EF4-FFF2-40B4-BE49-F238E27FC236}">
-                <a16:creationId xmlns:a16="http://schemas.microsoft.com/office/drawing/2014/main" id="{4DF58262-EB23-4D35-8BD2-FBAEE31CB15B}"/>
+                <a16:creationId xmlns:a16="http://schemas.microsoft.com/office/drawing/2014/main" id="{3AB64039-1C82-40A6-BCBA-0FF28061D2D8}"/>
               </a:ext>
             </a:extLst>
           </p:cNvPr>
@@ -20788,7 +20617,7 @@
                 <a:ea typeface="Arial"/>
                 <a:cs typeface="Arial"/>
               </a:rPr>
-              <a:t>A 64-bit CPU can have wider registers</a:t>
+              <a:t>Hex, binary, and byte order</a:t>
             </a:r>
           </a:p>
         </p:txBody>
@@ -21024,7 +20853,7 @@
                 <a:ea typeface="Arial"/>
                 <a:cs typeface="Arial"/>
               </a:rPr>
-              <a:t>The machine’s common integer-register width does not set the maximum size of every register.</a:t>
+              <a:t>One hex digit represents four bits. Convert one digit at a time.</a:t>
             </a:r>
           </a:p>
           <a:p xmlns:a="http://schemas.openxmlformats.org/drawingml/2006/main">
@@ -21074,7 +20903,7 @@
                 <a:ea typeface="Arial"/>
                 <a:cs typeface="Arial"/>
               </a:rPr>
-              <a:t>An XMM register can hold a scalar 32-bit float even though the register itself is 128 bits wide.</a:t>
+              <a:t>Endianness orders bytes in memory; it does not reverse the bits within each byte.</a:t>
             </a:r>
           </a:p>
           <a:p xmlns:a="http://schemas.openxmlformats.org/drawingml/2006/main">
@@ -21124,7 +20953,7 @@
                 <a:ea typeface="Arial"/>
                 <a:cs typeface="Arial"/>
               </a:rPr>
-              <a:t>Wider extensions depend on the supported instruction set.</a:t>
+              <a:t>Start at the lowest address when listing stored bytes.</a:t>
             </a:r>
           </a:p>
         </p:txBody>
@@ -21360,7 +21189,7 @@
                 <a:ea typeface="Consolas"/>
                 <a:cs typeface="Consolas"/>
               </a:rPr>
-              <a:t>x87: 80-bit floating-point registers</a:t>
+              <a:t>0xD6 = 1101 0110₂</a:t>
             </a:r>
           </a:p>
           <a:p xmlns:a="http://schemas.openxmlformats.org/drawingml/2006/main">
@@ -21393,7 +21222,7 @@
                 <a:ea typeface="Consolas"/>
                 <a:cs typeface="Consolas"/>
               </a:rPr>
-              <a:t>XMM: 128 bits = 16 bytes</a:t>
+              <a:t>0x1234, low address first:</a:t>
             </a:r>
           </a:p>
           <a:p xmlns:a="http://schemas.openxmlformats.org/drawingml/2006/main">
@@ -21426,7 +21255,7 @@
                 <a:ea typeface="Consolas"/>
                 <a:cs typeface="Consolas"/>
               </a:rPr>
-              <a:t>YMM: 256 bits = 32 bytes</a:t>
+              <a:t>Little endian: 34 12</a:t>
             </a:r>
           </a:p>
           <a:p xmlns:a="http://schemas.openxmlformats.org/drawingml/2006/main">
@@ -21459,7 +21288,7 @@
                 <a:ea typeface="Consolas"/>
                 <a:cs typeface="Consolas"/>
               </a:rPr>
-              <a:t>ZMM: 512 bits = 64 bytes (AVX-512)</a:t>
+              <a:t>Big endian:    12 34</a:t>
             </a:r>
           </a:p>
           <a:p xmlns:a="http://schemas.openxmlformats.org/drawingml/2006/main">
@@ -21509,7 +21338,7 @@
                 <a:ea typeface="Consolas"/>
                 <a:cs typeface="Consolas"/>
               </a:rPr>
-              <a:t>movss / addss: low scalar FP32</a:t>
+              <a:t>Your turn:</a:t>
             </a:r>
           </a:p>
           <a:p xmlns:a="http://schemas.openxmlformats.org/drawingml/2006/main">
@@ -21542,7 +21371,40 @@
                 <a:ea typeface="Consolas"/>
                 <a:cs typeface="Consolas"/>
               </a:rPr>
-              <a:t>movsd / addsd: low scalar FP64</a:t>
+              <a:t>1. 0xA7 in binary?</a:t>
+            </a:r>
+          </a:p>
+          <a:p xmlns:a="http://schemas.openxmlformats.org/drawingml/2006/main">
+            <a:pPr marL="0" indent="0">
+              <a:lnSpc>
+                <a:spcPct val="112000"/>
+              </a:lnSpc>
+              <a:spcBef>
+                <a:spcPts val="0"/>
+              </a:spcBef>
+              <a:spcAft>
+                <a:spcPts val="0"/>
+              </a:spcAft>
+              <a:buNone/>
+              <a:defRPr sz="1800">
+                <a:solidFill>
+                  <a:srgbClr val="FFFFFF"/>
+                </a:solidFill>
+                <a:latin typeface="Consolas"/>
+                <a:ea typeface="Consolas"/>
+                <a:cs typeface="Consolas"/>
+              </a:defRPr>
+            </a:pPr>
+            <a:r>
+              <a:rPr sz="1800">
+                <a:solidFill>
+                  <a:srgbClr val="FFFFFF"/>
+                </a:solidFill>
+                <a:latin typeface="Consolas"/>
+                <a:ea typeface="Consolas"/>
+                <a:cs typeface="Consolas"/>
+              </a:rPr>
+              <a:t>2. Bytes of 0xA7B2, little-endian?</a:t>
             </a:r>
           </a:p>
         </p:txBody>
@@ -21552,7 +21414,7 @@
           <p:cNvPr id="534" name="Takeaway">
             <a:extLst xmlns:a="http://schemas.openxmlformats.org/drawingml/2006/main">
               <a:ext uri="{FF2B5EF4-FFF2-40B4-BE49-F238E27FC236}">
-                <a16:creationId xmlns:a16="http://schemas.microsoft.com/office/drawing/2014/main" id="{812A45D3-92CA-4E5D-BD87-4E21314A084A}"/>
+                <a16:creationId xmlns:a16="http://schemas.microsoft.com/office/drawing/2014/main" id="{391D6956-D8A2-4783-945F-6EEC3B572E63}"/>
               </a:ext>
             </a:extLst>
           </p:cNvPr>
@@ -21710,7 +21572,7 @@
                 <a:ea typeface="Arial"/>
                 <a:cs typeface="Arial"/>
               </a:rPr>
-              <a:t>There is no universal “largest register = 64 bits” rule for a 64-bit system.</a:t>
+              <a:t>Same numeric value, different byte order in memory.</a:t>
             </a:r>
           </a:p>
         </p:txBody>
@@ -22221,7 +22083,7 @@
                 <a:ea typeface="Arial"/>
                 <a:cs typeface="Arial"/>
               </a:rPr>
-              <a:t>Hex, binary, and byte order</a:t>
+              <a:t>Signed values use the same bit patterns</a:t>
             </a:r>
           </a:p>
         </p:txBody>
@@ -22457,7 +22319,7 @@
                 <a:ea typeface="Arial"/>
                 <a:cs typeface="Arial"/>
               </a:rPr>
-              <a:t>One hex digit represents four bits. Convert one digit at a time.</a:t>
+              <a:t>n bits provide 2^n distinct patterns. Signed and unsigned interpretation assign different meanings to those patterns.</a:t>
             </a:r>
           </a:p>
           <a:p xmlns:a="http://schemas.openxmlformats.org/drawingml/2006/main">
@@ -22507,57 +22369,7 @@
                 <a:ea typeface="Arial"/>
                 <a:cs typeface="Arial"/>
               </a:rPr>
-              <a:t>Endianness orders bytes in memory; it does not reverse the bits within each byte.</a:t>
-            </a:r>
-          </a:p>
-          <a:p xmlns:a="http://schemas.openxmlformats.org/drawingml/2006/main">
-            <a:pPr marL="0" indent="0">
-              <a:lnSpc>
-                <a:spcPct val="112000"/>
-              </a:lnSpc>
-              <a:spcBef>
-                <a:spcPts val="0"/>
-              </a:spcBef>
-              <a:spcAft>
-                <a:spcPts val="0"/>
-              </a:spcAft>
-              <a:buNone/>
-            </a:pPr>
-            <a:r>
-              <a:t/>
-            </a:r>
-          </a:p>
-          <a:p xmlns:a="http://schemas.openxmlformats.org/drawingml/2006/main">
-            <a:pPr marL="0" indent="0">
-              <a:lnSpc>
-                <a:spcPct val="112000"/>
-              </a:lnSpc>
-              <a:spcBef>
-                <a:spcPts val="0"/>
-              </a:spcBef>
-              <a:spcAft>
-                <a:spcPts val="0"/>
-              </a:spcAft>
-              <a:buNone/>
-              <a:defRPr sz="1875">
-                <a:solidFill>
-                  <a:srgbClr val="FFFFFF"/>
-                </a:solidFill>
-                <a:latin typeface="Arial"/>
-                <a:ea typeface="Arial"/>
-                <a:cs typeface="Arial"/>
-              </a:defRPr>
-            </a:pPr>
-            <a:r>
-              <a:rPr sz="1875">
-                <a:solidFill>
-                  <a:srgbClr val="FFFFFF"/>
-                </a:solidFill>
-                <a:latin typeface="Arial"/>
-                <a:ea typeface="Arial"/>
-                <a:cs typeface="Arial"/>
-              </a:rPr>
-              <a:t>Start at the lowest address when listing stored bytes.</a:t>
+              <a:t>For 8-bit two’s complement, the range is −128 through 127. Negation flips the bits and adds 1, keeping 8 bits.</a:t>
             </a:r>
           </a:p>
         </p:txBody>
@@ -22793,7 +22605,7 @@
                 <a:ea typeface="Consolas"/>
                 <a:cs typeface="Consolas"/>
               </a:rPr>
-              <a:t>0xD6 = 1101 0110₂</a:t>
+              <a:t>8-bit pattern: 11111111</a:t>
             </a:r>
           </a:p>
           <a:p xmlns:a="http://schemas.openxmlformats.org/drawingml/2006/main">
@@ -22826,7 +22638,7 @@
                 <a:ea typeface="Consolas"/>
                 <a:cs typeface="Consolas"/>
               </a:rPr>
-              <a:t>0x1234, low address first:</a:t>
+              <a:t>Unsigned meaning: 255</a:t>
             </a:r>
           </a:p>
           <a:p xmlns:a="http://schemas.openxmlformats.org/drawingml/2006/main">
@@ -22859,7 +22671,24 @@
                 <a:ea typeface="Consolas"/>
                 <a:cs typeface="Consolas"/>
               </a:rPr>
-              <a:t>Little endian: 34 12</a:t>
+              <a:t>Signed meaning:   −1</a:t>
+            </a:r>
+          </a:p>
+          <a:p xmlns:a="http://schemas.openxmlformats.org/drawingml/2006/main">
+            <a:pPr marL="0" indent="0">
+              <a:lnSpc>
+                <a:spcPct val="112000"/>
+              </a:lnSpc>
+              <a:spcBef>
+                <a:spcPts val="0"/>
+              </a:spcBef>
+              <a:spcAft>
+                <a:spcPts val="0"/>
+              </a:spcAft>
+              <a:buNone/>
+            </a:pPr>
+            <a:r>
+              <a:t/>
             </a:r>
           </a:p>
           <a:p xmlns:a="http://schemas.openxmlformats.org/drawingml/2006/main">
@@ -22892,24 +22721,7 @@
                 <a:ea typeface="Consolas"/>
                 <a:cs typeface="Consolas"/>
               </a:rPr>
-              <a:t>Big endian:    12 34</a:t>
-            </a:r>
-          </a:p>
-          <a:p xmlns:a="http://schemas.openxmlformats.org/drawingml/2006/main">
-            <a:pPr marL="0" indent="0">
-              <a:lnSpc>
-                <a:spcPct val="112000"/>
-              </a:lnSpc>
-              <a:spcBef>
-                <a:spcPts val="0"/>
-              </a:spcBef>
-              <a:spcAft>
-                <a:spcPts val="0"/>
-              </a:spcAft>
-              <a:buNone/>
-            </a:pPr>
-            <a:r>
-              <a:t/>
+              <a:t>Negate 10000000 in 8 bits:</a:t>
             </a:r>
           </a:p>
           <a:p xmlns:a="http://schemas.openxmlformats.org/drawingml/2006/main">
@@ -22942,7 +22754,7 @@
                 <a:ea typeface="Consolas"/>
                 <a:cs typeface="Consolas"/>
               </a:rPr>
-              <a:t>Your turn:</a:t>
+              <a:t>Flip: 01111111</a:t>
             </a:r>
           </a:p>
           <a:p xmlns:a="http://schemas.openxmlformats.org/drawingml/2006/main">
@@ -22975,40 +22787,7 @@
                 <a:ea typeface="Consolas"/>
                 <a:cs typeface="Consolas"/>
               </a:rPr>
-              <a:t>1. 0xA7 in binary?</a:t>
-            </a:r>
-          </a:p>
-          <a:p xmlns:a="http://schemas.openxmlformats.org/drawingml/2006/main">
-            <a:pPr marL="0" indent="0">
-              <a:lnSpc>
-                <a:spcPct val="112000"/>
-              </a:lnSpc>
-              <a:spcBef>
-                <a:spcPts val="0"/>
-              </a:spcBef>
-              <a:spcAft>
-                <a:spcPts val="0"/>
-              </a:spcAft>
-              <a:buNone/>
-              <a:defRPr sz="1800">
-                <a:solidFill>
-                  <a:srgbClr val="FFFFFF"/>
-                </a:solidFill>
-                <a:latin typeface="Consolas"/>
-                <a:ea typeface="Consolas"/>
-                <a:cs typeface="Consolas"/>
-              </a:defRPr>
-            </a:pPr>
-            <a:r>
-              <a:rPr sz="1800">
-                <a:solidFill>
-                  <a:srgbClr val="FFFFFF"/>
-                </a:solidFill>
-                <a:latin typeface="Consolas"/>
-                <a:ea typeface="Consolas"/>
-                <a:cs typeface="Consolas"/>
-              </a:rPr>
-              <a:t>2. Bytes of 0xA7B2, little-endian?</a:t>
+              <a:t>Add 1: 10000000</a:t>
             </a:r>
           </a:p>
         </p:txBody>
@@ -23018,7 +22797,7 @@
           <p:cNvPr id="534" name="Takeaway">
             <a:extLst xmlns:a="http://schemas.openxmlformats.org/drawingml/2006/main">
               <a:ext uri="{FF2B5EF4-FFF2-40B4-BE49-F238E27FC236}">
-                <a16:creationId xmlns:a16="http://schemas.microsoft.com/office/drawing/2014/main" id="{A299AB3F-CAC7-45C6-B905-56803A147272}"/>
+                <a16:creationId xmlns:a16="http://schemas.microsoft.com/office/drawing/2014/main" id="{088693FA-538C-4604-8AAE-CE245EFAFE41}"/>
               </a:ext>
             </a:extLst>
           </p:cNvPr>
@@ -23176,7 +22955,7 @@
                 <a:ea typeface="Arial"/>
                 <a:cs typeface="Arial"/>
               </a:rPr>
-              <a:t>Same numeric value, different byte order in memory.</a:t>
+              <a:t>Mathematically +128 cannot fit in a signed 8-bit result.</a:t>
             </a:r>
           </a:p>
         </p:txBody>
@@ -24302,7 +24081,7 @@
           <p:cNvPr id="534" name="">
             <a:extLst xmlns:a="http://schemas.openxmlformats.org/drawingml/2006/main">
               <a:ext uri="{FF2B5EF4-FFF2-40B4-BE49-F238E27FC236}">
-                <a16:creationId xmlns:a16="http://schemas.microsoft.com/office/drawing/2014/main" id="{354148E4-91DD-4091-9755-846CBD5FC793}"/>
+                <a16:creationId xmlns:a16="http://schemas.microsoft.com/office/drawing/2014/main" id="{03179E62-FFE6-4C91-9F4F-8D38672E70F9}"/>
               </a:ext>
             </a:extLst>
           </p:cNvPr>
@@ -24662,7 +24441,7 @@
           <p:cNvPr id="535" name="Takeaway">
             <a:extLst xmlns:a="http://schemas.openxmlformats.org/drawingml/2006/main">
               <a:ext uri="{FF2B5EF4-FFF2-40B4-BE49-F238E27FC236}">
-                <a16:creationId xmlns:a16="http://schemas.microsoft.com/office/drawing/2014/main" id="{37164DC2-CFF4-442E-B39A-AACBDA7912AF}"/>
+                <a16:creationId xmlns:a16="http://schemas.microsoft.com/office/drawing/2014/main" id="{3100A582-35DA-4603-B89F-1EC47260928D}"/>
               </a:ext>
             </a:extLst>
           </p:cNvPr>
@@ -25331,7 +25110,7 @@
                 <a:ea typeface="Arial"/>
                 <a:cs typeface="Arial"/>
               </a:rPr>
-              <a:t>Signed values use the same bit patterns</a:t>
+              <a:t>Masks, shifts, and rotations</a:t>
             </a:r>
           </a:p>
         </p:txBody>
@@ -25567,7 +25346,7 @@
                 <a:ea typeface="Arial"/>
                 <a:cs typeface="Arial"/>
               </a:rPr>
-              <a:t>n bits provide 2^n distinct patterns. Signed and unsigned interpretation assign different meanings to those patterns.</a:t>
+              <a:t>AND keeps only bits selected by a mask. OR sets selected bits. XOR flips selected bits.</a:t>
             </a:r>
           </a:p>
           <a:p xmlns:a="http://schemas.openxmlformats.org/drawingml/2006/main">
@@ -25617,7 +25396,57 @@
                 <a:ea typeface="Arial"/>
                 <a:cs typeface="Arial"/>
               </a:rPr>
-              <a:t>For 8-bit two’s complement, the range is −128 through 127. Negation flips the bits and adds 1, keeping 8 bits.</a:t>
+              <a:t>A shift drops bits from one end. A rotation brings those bits around to the other end.</a:t>
+            </a:r>
+          </a:p>
+          <a:p xmlns:a="http://schemas.openxmlformats.org/drawingml/2006/main">
+            <a:pPr marL="0" indent="0">
+              <a:lnSpc>
+                <a:spcPct val="112000"/>
+              </a:lnSpc>
+              <a:spcBef>
+                <a:spcPts val="0"/>
+              </a:spcBef>
+              <a:spcAft>
+                <a:spcPts val="0"/>
+              </a:spcAft>
+              <a:buNone/>
+            </a:pPr>
+            <a:r>
+              <a:t/>
+            </a:r>
+          </a:p>
+          <a:p xmlns:a="http://schemas.openxmlformats.org/drawingml/2006/main">
+            <a:pPr marL="0" indent="0">
+              <a:lnSpc>
+                <a:spcPct val="112000"/>
+              </a:lnSpc>
+              <a:spcBef>
+                <a:spcPts val="0"/>
+              </a:spcBef>
+              <a:spcAft>
+                <a:spcPts val="0"/>
+              </a:spcAft>
+              <a:buNone/>
+              <a:defRPr sz="1875">
+                <a:solidFill>
+                  <a:srgbClr val="FFFFFF"/>
+                </a:solidFill>
+                <a:latin typeface="Arial"/>
+                <a:ea typeface="Arial"/>
+                <a:cs typeface="Arial"/>
+              </a:defRPr>
+            </a:pPr>
+            <a:r>
+              <a:rPr sz="1875">
+                <a:solidFill>
+                  <a:srgbClr val="FFFFFF"/>
+                </a:solidFill>
+                <a:latin typeface="Arial"/>
+                <a:ea typeface="Arial"/>
+                <a:cs typeface="Arial"/>
+              </a:rPr>
+              <a:t>Use an explicitly unsigned 8-bit model here.</a:t>
             </a:r>
           </a:p>
         </p:txBody>
@@ -25853,7 +25682,24 @@
                 <a:ea typeface="Consolas"/>
                 <a:cs typeface="Consolas"/>
               </a:rPr>
-              <a:t>8-bit pattern: 11111111</a:t>
+              <a:t>x = 0xB6 = 10110110₂</a:t>
+            </a:r>
+          </a:p>
+          <a:p xmlns:a="http://schemas.openxmlformats.org/drawingml/2006/main">
+            <a:pPr marL="0" indent="0">
+              <a:lnSpc>
+                <a:spcPct val="112000"/>
+              </a:lnSpc>
+              <a:spcBef>
+                <a:spcPts val="0"/>
+              </a:spcBef>
+              <a:spcAft>
+                <a:spcPts val="0"/>
+              </a:spcAft>
+              <a:buNone/>
+            </a:pPr>
+            <a:r>
+              <a:t/>
             </a:r>
           </a:p>
           <a:p xmlns:a="http://schemas.openxmlformats.org/drawingml/2006/main">
@@ -25886,7 +25732,7 @@
                 <a:ea typeface="Consolas"/>
                 <a:cs typeface="Consolas"/>
               </a:rPr>
-              <a:t>Unsigned meaning: 255</a:t>
+              <a:t>x &amp; 0x0F = ?</a:t>
             </a:r>
           </a:p>
           <a:p xmlns:a="http://schemas.openxmlformats.org/drawingml/2006/main">
@@ -25919,24 +25765,7 @@
                 <a:ea typeface="Consolas"/>
                 <a:cs typeface="Consolas"/>
               </a:rPr>
-              <a:t>Signed meaning:   −1</a:t>
-            </a:r>
-          </a:p>
-          <a:p xmlns:a="http://schemas.openxmlformats.org/drawingml/2006/main">
-            <a:pPr marL="0" indent="0">
-              <a:lnSpc>
-                <a:spcPct val="112000"/>
-              </a:lnSpc>
-              <a:spcBef>
-                <a:spcPts val="0"/>
-              </a:spcBef>
-              <a:spcAft>
-                <a:spcPts val="0"/>
-              </a:spcAft>
-              <a:buNone/>
-            </a:pPr>
-            <a:r>
-              <a:t/>
+              <a:t>(x &lt;&lt; 1) &amp; 0xFF = ?</a:t>
             </a:r>
           </a:p>
           <a:p xmlns:a="http://schemas.openxmlformats.org/drawingml/2006/main">
@@ -25969,73 +25798,7 @@
                 <a:ea typeface="Consolas"/>
                 <a:cs typeface="Consolas"/>
               </a:rPr>
-              <a:t>Negate 10000000 in 8 bits:</a:t>
-            </a:r>
-          </a:p>
-          <a:p xmlns:a="http://schemas.openxmlformats.org/drawingml/2006/main">
-            <a:pPr marL="0" indent="0">
-              <a:lnSpc>
-                <a:spcPct val="112000"/>
-              </a:lnSpc>
-              <a:spcBef>
-                <a:spcPts val="0"/>
-              </a:spcBef>
-              <a:spcAft>
-                <a:spcPts val="0"/>
-              </a:spcAft>
-              <a:buNone/>
-              <a:defRPr sz="1800">
-                <a:solidFill>
-                  <a:srgbClr val="FFFFFF"/>
-                </a:solidFill>
-                <a:latin typeface="Consolas"/>
-                <a:ea typeface="Consolas"/>
-                <a:cs typeface="Consolas"/>
-              </a:defRPr>
-            </a:pPr>
-            <a:r>
-              <a:rPr sz="1800">
-                <a:solidFill>
-                  <a:srgbClr val="FFFFFF"/>
-                </a:solidFill>
-                <a:latin typeface="Consolas"/>
-                <a:ea typeface="Consolas"/>
-                <a:cs typeface="Consolas"/>
-              </a:rPr>
-              <a:t>Flip: 01111111</a:t>
-            </a:r>
-          </a:p>
-          <a:p xmlns:a="http://schemas.openxmlformats.org/drawingml/2006/main">
-            <a:pPr marL="0" indent="0">
-              <a:lnSpc>
-                <a:spcPct val="112000"/>
-              </a:lnSpc>
-              <a:spcBef>
-                <a:spcPts val="0"/>
-              </a:spcBef>
-              <a:spcAft>
-                <a:spcPts val="0"/>
-              </a:spcAft>
-              <a:buNone/>
-              <a:defRPr sz="1800">
-                <a:solidFill>
-                  <a:srgbClr val="FFFFFF"/>
-                </a:solidFill>
-                <a:latin typeface="Consolas"/>
-                <a:ea typeface="Consolas"/>
-                <a:cs typeface="Consolas"/>
-              </a:defRPr>
-            </a:pPr>
-            <a:r>
-              <a:rPr sz="1800">
-                <a:solidFill>
-                  <a:srgbClr val="FFFFFF"/>
-                </a:solidFill>
-                <a:latin typeface="Consolas"/>
-                <a:ea typeface="Consolas"/>
-                <a:cs typeface="Consolas"/>
-              </a:rPr>
-              <a:t>Add 1: 10000000</a:t>
+              <a:t>Rotate left by 1 within 8 bits = ?</a:t>
             </a:r>
           </a:p>
         </p:txBody>
@@ -26045,7 +25808,7 @@
           <p:cNvPr id="534" name="Takeaway">
             <a:extLst xmlns:a="http://schemas.openxmlformats.org/drawingml/2006/main">
               <a:ext uri="{FF2B5EF4-FFF2-40B4-BE49-F238E27FC236}">
-                <a16:creationId xmlns:a16="http://schemas.microsoft.com/office/drawing/2014/main" id="{DE634C2C-0898-4853-A5C4-D01918BBB8B2}"/>
+                <a16:creationId xmlns:a16="http://schemas.microsoft.com/office/drawing/2014/main" id="{A2E452FF-9994-4D14-A931-464BE5FC2262}"/>
               </a:ext>
             </a:extLst>
           </p:cNvPr>
@@ -26203,7 +25966,7 @@
                 <a:ea typeface="Arial"/>
                 <a:cs typeface="Arial"/>
               </a:rPr>
-              <a:t>Mathematically +128 cannot fit in a signed 8-bit result.</a:t>
+              <a:t>Keep the chosen width explicit; C integer promotions do not automatically limit x &lt;&lt; 1 to 8 bits.</a:t>
             </a:r>
           </a:p>
         </p:txBody>
@@ -26714,7 +26477,7 @@
                 <a:ea typeface="Arial"/>
                 <a:cs typeface="Arial"/>
               </a:rPr>
-              <a:t>Masks, shifts, and rotations</a:t>
+              <a:t>Build a truth table one gate at a time</a:t>
             </a:r>
           </a:p>
         </p:txBody>
@@ -26950,1373 +26713,6 @@
                 <a:ea typeface="Arial"/>
                 <a:cs typeface="Arial"/>
               </a:rPr>
-              <a:t>AND keeps only bits selected by a mask. OR sets selected bits. XOR flips selected bits.</a:t>
-            </a:r>
-          </a:p>
-          <a:p xmlns:a="http://schemas.openxmlformats.org/drawingml/2006/main">
-            <a:pPr marL="0" indent="0">
-              <a:lnSpc>
-                <a:spcPct val="112000"/>
-              </a:lnSpc>
-              <a:spcBef>
-                <a:spcPts val="0"/>
-              </a:spcBef>
-              <a:spcAft>
-                <a:spcPts val="0"/>
-              </a:spcAft>
-              <a:buNone/>
-            </a:pPr>
-            <a:r>
-              <a:t/>
-            </a:r>
-          </a:p>
-          <a:p xmlns:a="http://schemas.openxmlformats.org/drawingml/2006/main">
-            <a:pPr marL="0" indent="0">
-              <a:lnSpc>
-                <a:spcPct val="112000"/>
-              </a:lnSpc>
-              <a:spcBef>
-                <a:spcPts val="0"/>
-              </a:spcBef>
-              <a:spcAft>
-                <a:spcPts val="0"/>
-              </a:spcAft>
-              <a:buNone/>
-              <a:defRPr sz="1875">
-                <a:solidFill>
-                  <a:srgbClr val="FFFFFF"/>
-                </a:solidFill>
-                <a:latin typeface="Arial"/>
-                <a:ea typeface="Arial"/>
-                <a:cs typeface="Arial"/>
-              </a:defRPr>
-            </a:pPr>
-            <a:r>
-              <a:rPr sz="1875">
-                <a:solidFill>
-                  <a:srgbClr val="FFFFFF"/>
-                </a:solidFill>
-                <a:latin typeface="Arial"/>
-                <a:ea typeface="Arial"/>
-                <a:cs typeface="Arial"/>
-              </a:rPr>
-              <a:t>A shift drops bits from one end. A rotation brings those bits around to the other end.</a:t>
-            </a:r>
-          </a:p>
-          <a:p xmlns:a="http://schemas.openxmlformats.org/drawingml/2006/main">
-            <a:pPr marL="0" indent="0">
-              <a:lnSpc>
-                <a:spcPct val="112000"/>
-              </a:lnSpc>
-              <a:spcBef>
-                <a:spcPts val="0"/>
-              </a:spcBef>
-              <a:spcAft>
-                <a:spcPts val="0"/>
-              </a:spcAft>
-              <a:buNone/>
-            </a:pPr>
-            <a:r>
-              <a:t/>
-            </a:r>
-          </a:p>
-          <a:p xmlns:a="http://schemas.openxmlformats.org/drawingml/2006/main">
-            <a:pPr marL="0" indent="0">
-              <a:lnSpc>
-                <a:spcPct val="112000"/>
-              </a:lnSpc>
-              <a:spcBef>
-                <a:spcPts val="0"/>
-              </a:spcBef>
-              <a:spcAft>
-                <a:spcPts val="0"/>
-              </a:spcAft>
-              <a:buNone/>
-              <a:defRPr sz="1875">
-                <a:solidFill>
-                  <a:srgbClr val="FFFFFF"/>
-                </a:solidFill>
-                <a:latin typeface="Arial"/>
-                <a:ea typeface="Arial"/>
-                <a:cs typeface="Arial"/>
-              </a:defRPr>
-            </a:pPr>
-            <a:r>
-              <a:rPr sz="1875">
-                <a:solidFill>
-                  <a:srgbClr val="FFFFFF"/>
-                </a:solidFill>
-                <a:latin typeface="Arial"/>
-                <a:ea typeface="Arial"/>
-                <a:cs typeface="Arial"/>
-              </a:rPr>
-              <a:t>Use an explicitly unsigned 8-bit model here.</a:t>
-            </a:r>
-          </a:p>
-        </p:txBody>
-      </p:sp>
-      <p:sp>
-        <p:nvSpPr>
-          <p:cNvPr id="8" name="Content Placeholder 3">
-            <a:extLst xmlns:a="http://schemas.openxmlformats.org/drawingml/2006/main">
-              <a:ext uri="{FF2B5EF4-FFF2-40B4-BE49-F238E27FC236}">
-                <a16:creationId xmlns:a16="http://schemas.microsoft.com/office/drawing/2014/main" id="{2EE8F343-A95F-2AAA-FE9E-A6C31E298DF7}"/>
-              </a:ext>
-            </a:extLst>
-          </p:cNvPr>
-          <p:cNvSpPr>
-            <a:spLocks xmlns:a="http://schemas.openxmlformats.org/drawingml/2006/main" noGrp="1"/>
-          </p:cNvSpPr>
-          <p:nvPr/>
-        </p:nvSpPr>
-        <p:spPr>
-          <a:xfrm xmlns:a="http://schemas.openxmlformats.org/drawingml/2006/main">
-            <a:off x="6256618" y="2031999"/>
-            <a:ext cx="5537200" cy="3534787"/>
-          </a:xfrm>
-          <a:prstGeom xmlns:a="http://schemas.openxmlformats.org/drawingml/2006/main" prst="rect">
-            <a:avLst/>
-          </a:prstGeom>
-        </p:spPr>
-        <p:txBody>
-          <a:bodyPr xmlns:a="http://schemas.openxmlformats.org/drawingml/2006/main" lIns="0" tIns="0" rIns="0" bIns="0" anchor="t">
-            <a:noAutofit/>
-          </a:bodyPr>
-          <a:lstStyle xmlns:a="http://schemas.openxmlformats.org/drawingml/2006/main">
-            <a:defPPr>
-              <a:defRPr sz="1800">
-                <a:solidFill>
-                  <a:srgbClr val="FFFFFF"/>
-                </a:solidFill>
-                <a:latin typeface="Consolas"/>
-                <a:ea typeface="Consolas"/>
-                <a:cs typeface="Consolas"/>
-              </a:defRPr>
-            </a:defPPr>
-            <a:lvl1pPr marL="228600" indent="-228600" algn="l" defTabSz="914400">
-              <a:lnSpc>
-                <a:spcPct val="90000"/>
-              </a:lnSpc>
-              <a:spcBef>
-                <a:spcPts val="1000"/>
-              </a:spcBef>
-              <a:buFont typeface="Arial"/>
-              <a:buChar char="•"/>
-              <a:defRPr sz="2400" kern="1200">
-                <a:solidFill>
-                  <a:schemeClr val="tx1"/>
-                </a:solidFill>
-                <a:latin typeface="+mn-lt"/>
-                <a:ea typeface="+mn-lt"/>
-                <a:cs typeface="+mn-lt"/>
-              </a:defRPr>
-            </a:lvl1pPr>
-            <a:lvl2pPr marL="685800" indent="-228600" algn="l" defTabSz="914400">
-              <a:lnSpc>
-                <a:spcPct val="90000"/>
-              </a:lnSpc>
-              <a:spcBef>
-                <a:spcPts val="500"/>
-              </a:spcBef>
-              <a:buFont typeface="Arial"/>
-              <a:buChar char="•"/>
-              <a:defRPr sz="2000" kern="1200">
-                <a:solidFill>
-                  <a:schemeClr val="tx1"/>
-                </a:solidFill>
-                <a:latin typeface="+mn-lt"/>
-                <a:ea typeface="+mn-lt"/>
-                <a:cs typeface="+mn-lt"/>
-              </a:defRPr>
-            </a:lvl2pPr>
-            <a:lvl3pPr marL="1143000" indent="-228600" algn="l" defTabSz="914400">
-              <a:lnSpc>
-                <a:spcPct val="90000"/>
-              </a:lnSpc>
-              <a:spcBef>
-                <a:spcPts val="500"/>
-              </a:spcBef>
-              <a:buFont typeface="Arial"/>
-              <a:buChar char="•"/>
-              <a:defRPr sz="1800" kern="1200">
-                <a:solidFill>
-                  <a:schemeClr val="tx1"/>
-                </a:solidFill>
-                <a:latin typeface="+mn-lt"/>
-                <a:ea typeface="+mn-lt"/>
-                <a:cs typeface="+mn-lt"/>
-              </a:defRPr>
-            </a:lvl3pPr>
-            <a:lvl4pPr marL="1600200" indent="-228600" algn="l" defTabSz="914400">
-              <a:lnSpc>
-                <a:spcPct val="90000"/>
-              </a:lnSpc>
-              <a:spcBef>
-                <a:spcPts val="500"/>
-              </a:spcBef>
-              <a:buFont typeface="Arial"/>
-              <a:buChar char="•"/>
-              <a:defRPr sz="1800" kern="1200">
-                <a:solidFill>
-                  <a:schemeClr val="tx1"/>
-                </a:solidFill>
-                <a:latin typeface="+mn-lt"/>
-                <a:ea typeface="+mn-lt"/>
-                <a:cs typeface="+mn-lt"/>
-              </a:defRPr>
-            </a:lvl4pPr>
-            <a:lvl5pPr marL="2057400" indent="-228600" algn="l" defTabSz="914400">
-              <a:lnSpc>
-                <a:spcPct val="90000"/>
-              </a:lnSpc>
-              <a:spcBef>
-                <a:spcPts val="500"/>
-              </a:spcBef>
-              <a:buFont typeface="Arial"/>
-              <a:buChar char="•"/>
-              <a:defRPr sz="1800" kern="1200">
-                <a:solidFill>
-                  <a:schemeClr val="tx1"/>
-                </a:solidFill>
-                <a:latin typeface="+mn-lt"/>
-                <a:ea typeface="+mn-lt"/>
-                <a:cs typeface="+mn-lt"/>
-              </a:defRPr>
-            </a:lvl5pPr>
-            <a:lvl6pPr marL="2514600" indent="-228600" algn="l" defTabSz="914400">
-              <a:lnSpc>
-                <a:spcPct val="90000"/>
-              </a:lnSpc>
-              <a:spcBef>
-                <a:spcPts val="500"/>
-              </a:spcBef>
-              <a:buFont typeface="Arial"/>
-              <a:buChar char="•"/>
-              <a:defRPr sz="1800" kern="1200">
-                <a:solidFill>
-                  <a:schemeClr val="tx1"/>
-                </a:solidFill>
-                <a:latin typeface="+mn-lt"/>
-                <a:ea typeface="+mn-lt"/>
-                <a:cs typeface="+mn-lt"/>
-              </a:defRPr>
-            </a:lvl6pPr>
-            <a:lvl7pPr marL="2971800" indent="-228600" algn="l" defTabSz="914400">
-              <a:lnSpc>
-                <a:spcPct val="90000"/>
-              </a:lnSpc>
-              <a:spcBef>
-                <a:spcPts val="500"/>
-              </a:spcBef>
-              <a:buFont typeface="Arial"/>
-              <a:buChar char="•"/>
-              <a:defRPr sz="1800" kern="1200">
-                <a:solidFill>
-                  <a:schemeClr val="tx1"/>
-                </a:solidFill>
-                <a:latin typeface="+mn-lt"/>
-                <a:ea typeface="+mn-lt"/>
-                <a:cs typeface="+mn-lt"/>
-              </a:defRPr>
-            </a:lvl7pPr>
-            <a:lvl8pPr marL="3429000" indent="-228600" algn="l" defTabSz="914400">
-              <a:lnSpc>
-                <a:spcPct val="90000"/>
-              </a:lnSpc>
-              <a:spcBef>
-                <a:spcPts val="500"/>
-              </a:spcBef>
-              <a:buFont typeface="Arial"/>
-              <a:buChar char="•"/>
-              <a:defRPr sz="1800" kern="1200">
-                <a:solidFill>
-                  <a:schemeClr val="tx1"/>
-                </a:solidFill>
-                <a:latin typeface="+mn-lt"/>
-                <a:ea typeface="+mn-lt"/>
-                <a:cs typeface="+mn-lt"/>
-              </a:defRPr>
-            </a:lvl8pPr>
-            <a:lvl9pPr marL="3886200" indent="-228600" algn="l" defTabSz="914400">
-              <a:lnSpc>
-                <a:spcPct val="90000"/>
-              </a:lnSpc>
-              <a:spcBef>
-                <a:spcPts val="500"/>
-              </a:spcBef>
-              <a:buFont typeface="Arial"/>
-              <a:buChar char="•"/>
-              <a:defRPr sz="1800" kern="1200">
-                <a:solidFill>
-                  <a:schemeClr val="tx1"/>
-                </a:solidFill>
-                <a:latin typeface="+mn-lt"/>
-                <a:ea typeface="+mn-lt"/>
-                <a:cs typeface="+mn-lt"/>
-              </a:defRPr>
-            </a:lvl9pPr>
-          </a:lstStyle>
-          <a:p xmlns:a="http://schemas.openxmlformats.org/drawingml/2006/main">
-            <a:pPr marL="0" indent="0">
-              <a:lnSpc>
-                <a:spcPct val="112000"/>
-              </a:lnSpc>
-              <a:spcBef>
-                <a:spcPts val="0"/>
-              </a:spcBef>
-              <a:spcAft>
-                <a:spcPts val="0"/>
-              </a:spcAft>
-              <a:buNone/>
-              <a:defRPr sz="1800">
-                <a:solidFill>
-                  <a:srgbClr val="FFFFFF"/>
-                </a:solidFill>
-                <a:latin typeface="Consolas"/>
-                <a:ea typeface="Consolas"/>
-                <a:cs typeface="Consolas"/>
-              </a:defRPr>
-            </a:pPr>
-            <a:r>
-              <a:rPr sz="1800">
-                <a:solidFill>
-                  <a:srgbClr val="FFFFFF"/>
-                </a:solidFill>
-                <a:latin typeface="Consolas"/>
-                <a:ea typeface="Consolas"/>
-                <a:cs typeface="Consolas"/>
-              </a:rPr>
-              <a:t>x = 0xB6 = 10110110₂</a:t>
-            </a:r>
-          </a:p>
-          <a:p xmlns:a="http://schemas.openxmlformats.org/drawingml/2006/main">
-            <a:pPr marL="0" indent="0">
-              <a:lnSpc>
-                <a:spcPct val="112000"/>
-              </a:lnSpc>
-              <a:spcBef>
-                <a:spcPts val="0"/>
-              </a:spcBef>
-              <a:spcAft>
-                <a:spcPts val="0"/>
-              </a:spcAft>
-              <a:buNone/>
-            </a:pPr>
-            <a:r>
-              <a:t/>
-            </a:r>
-          </a:p>
-          <a:p xmlns:a="http://schemas.openxmlformats.org/drawingml/2006/main">
-            <a:pPr marL="0" indent="0">
-              <a:lnSpc>
-                <a:spcPct val="112000"/>
-              </a:lnSpc>
-              <a:spcBef>
-                <a:spcPts val="0"/>
-              </a:spcBef>
-              <a:spcAft>
-                <a:spcPts val="0"/>
-              </a:spcAft>
-              <a:buNone/>
-              <a:defRPr sz="1800">
-                <a:solidFill>
-                  <a:srgbClr val="FFFFFF"/>
-                </a:solidFill>
-                <a:latin typeface="Consolas"/>
-                <a:ea typeface="Consolas"/>
-                <a:cs typeface="Consolas"/>
-              </a:defRPr>
-            </a:pPr>
-            <a:r>
-              <a:rPr sz="1800">
-                <a:solidFill>
-                  <a:srgbClr val="FFFFFF"/>
-                </a:solidFill>
-                <a:latin typeface="Consolas"/>
-                <a:ea typeface="Consolas"/>
-                <a:cs typeface="Consolas"/>
-              </a:rPr>
-              <a:t>x &amp; 0x0F = ?</a:t>
-            </a:r>
-          </a:p>
-          <a:p xmlns:a="http://schemas.openxmlformats.org/drawingml/2006/main">
-            <a:pPr marL="0" indent="0">
-              <a:lnSpc>
-                <a:spcPct val="112000"/>
-              </a:lnSpc>
-              <a:spcBef>
-                <a:spcPts val="0"/>
-              </a:spcBef>
-              <a:spcAft>
-                <a:spcPts val="0"/>
-              </a:spcAft>
-              <a:buNone/>
-              <a:defRPr sz="1800">
-                <a:solidFill>
-                  <a:srgbClr val="FFFFFF"/>
-                </a:solidFill>
-                <a:latin typeface="Consolas"/>
-                <a:ea typeface="Consolas"/>
-                <a:cs typeface="Consolas"/>
-              </a:defRPr>
-            </a:pPr>
-            <a:r>
-              <a:rPr sz="1800">
-                <a:solidFill>
-                  <a:srgbClr val="FFFFFF"/>
-                </a:solidFill>
-                <a:latin typeface="Consolas"/>
-                <a:ea typeface="Consolas"/>
-                <a:cs typeface="Consolas"/>
-              </a:rPr>
-              <a:t>(x &lt;&lt; 1) &amp; 0xFF = ?</a:t>
-            </a:r>
-          </a:p>
-          <a:p xmlns:a="http://schemas.openxmlformats.org/drawingml/2006/main">
-            <a:pPr marL="0" indent="0">
-              <a:lnSpc>
-                <a:spcPct val="112000"/>
-              </a:lnSpc>
-              <a:spcBef>
-                <a:spcPts val="0"/>
-              </a:spcBef>
-              <a:spcAft>
-                <a:spcPts val="0"/>
-              </a:spcAft>
-              <a:buNone/>
-              <a:defRPr sz="1800">
-                <a:solidFill>
-                  <a:srgbClr val="FFFFFF"/>
-                </a:solidFill>
-                <a:latin typeface="Consolas"/>
-                <a:ea typeface="Consolas"/>
-                <a:cs typeface="Consolas"/>
-              </a:defRPr>
-            </a:pPr>
-            <a:r>
-              <a:rPr sz="1800">
-                <a:solidFill>
-                  <a:srgbClr val="FFFFFF"/>
-                </a:solidFill>
-                <a:latin typeface="Consolas"/>
-                <a:ea typeface="Consolas"/>
-                <a:cs typeface="Consolas"/>
-              </a:rPr>
-              <a:t>Rotate left by 1 within 8 bits = ?</a:t>
-            </a:r>
-          </a:p>
-        </p:txBody>
-      </p:sp>
-      <p:sp>
-        <p:nvSpPr>
-          <p:cNvPr id="534" name="Takeaway">
-            <a:extLst xmlns:a="http://schemas.openxmlformats.org/drawingml/2006/main">
-              <a:ext uri="{FF2B5EF4-FFF2-40B4-BE49-F238E27FC236}">
-                <a16:creationId xmlns:a16="http://schemas.microsoft.com/office/drawing/2014/main" id="{ED771414-6432-454D-8253-E68F1E8D3552}"/>
-              </a:ext>
-            </a:extLst>
-          </p:cNvPr>
-          <p:cNvSpPr>
-            <a:spLocks xmlns:a="http://schemas.openxmlformats.org/drawingml/2006/main" noGrp="1"/>
-          </p:cNvSpPr>
-          <p:nvPr/>
-        </p:nvSpPr>
-        <p:spPr>
-          <a:xfrm xmlns:a="http://schemas.openxmlformats.org/drawingml/2006/main">
-            <a:off x="393668" y="5715000"/>
-            <a:ext cx="11404283" cy="466725"/>
-          </a:xfrm>
-          <a:prstGeom xmlns:a="http://schemas.openxmlformats.org/drawingml/2006/main" prst="rect">
-            <a:avLst/>
-          </a:prstGeom>
-          <a:noFill xmlns:a="http://schemas.openxmlformats.org/drawingml/2006/main"/>
-          <a:ln xmlns:a="http://schemas.openxmlformats.org/drawingml/2006/main" w="0">
-            <a:noFill/>
-          </a:ln>
-        </p:spPr>
-        <p:txBody>
-          <a:bodyPr xmlns:a="http://schemas.openxmlformats.org/drawingml/2006/main" lIns="0" tIns="0" rIns="0" bIns="0" anchor="t">
-            <a:noAutofit/>
-          </a:bodyPr>
-          <a:lstStyle xmlns:a="http://schemas.openxmlformats.org/drawingml/2006/main">
-            <a:defPPr>
-              <a:defRPr sz="1350">
-                <a:solidFill>
-                  <a:srgbClr val="CCCCCC"/>
-                </a:solidFill>
-                <a:latin typeface="Arial"/>
-                <a:ea typeface="Arial"/>
-                <a:cs typeface="Arial"/>
-              </a:defRPr>
-            </a:defPPr>
-            <a:lvl1pPr>
-              <a:defRPr sz="1350">
-                <a:solidFill>
-                  <a:srgbClr val="CCCCCC"/>
-                </a:solidFill>
-                <a:latin typeface="Arial"/>
-                <a:ea typeface="Arial"/>
-                <a:cs typeface="Arial"/>
-              </a:defRPr>
-            </a:lvl1pPr>
-            <a:lvl2pPr>
-              <a:defRPr sz="1350">
-                <a:solidFill>
-                  <a:srgbClr val="CCCCCC"/>
-                </a:solidFill>
-                <a:latin typeface="Arial"/>
-                <a:ea typeface="Arial"/>
-                <a:cs typeface="Arial"/>
-              </a:defRPr>
-            </a:lvl2pPr>
-            <a:lvl3pPr>
-              <a:defRPr sz="1350">
-                <a:solidFill>
-                  <a:srgbClr val="CCCCCC"/>
-                </a:solidFill>
-                <a:latin typeface="Arial"/>
-                <a:ea typeface="Arial"/>
-                <a:cs typeface="Arial"/>
-              </a:defRPr>
-            </a:lvl3pPr>
-            <a:lvl4pPr>
-              <a:defRPr sz="1350">
-                <a:solidFill>
-                  <a:srgbClr val="CCCCCC"/>
-                </a:solidFill>
-                <a:latin typeface="Arial"/>
-                <a:ea typeface="Arial"/>
-                <a:cs typeface="Arial"/>
-              </a:defRPr>
-            </a:lvl4pPr>
-            <a:lvl5pPr>
-              <a:defRPr sz="1350">
-                <a:solidFill>
-                  <a:srgbClr val="CCCCCC"/>
-                </a:solidFill>
-                <a:latin typeface="Arial"/>
-                <a:ea typeface="Arial"/>
-                <a:cs typeface="Arial"/>
-              </a:defRPr>
-            </a:lvl5pPr>
-            <a:lvl6pPr>
-              <a:defRPr sz="1350">
-                <a:solidFill>
-                  <a:srgbClr val="CCCCCC"/>
-                </a:solidFill>
-                <a:latin typeface="Arial"/>
-                <a:ea typeface="Arial"/>
-                <a:cs typeface="Arial"/>
-              </a:defRPr>
-            </a:lvl6pPr>
-            <a:lvl7pPr>
-              <a:defRPr sz="1350">
-                <a:solidFill>
-                  <a:srgbClr val="CCCCCC"/>
-                </a:solidFill>
-                <a:latin typeface="Arial"/>
-                <a:ea typeface="Arial"/>
-                <a:cs typeface="Arial"/>
-              </a:defRPr>
-            </a:lvl7pPr>
-            <a:lvl8pPr>
-              <a:defRPr sz="1350">
-                <a:solidFill>
-                  <a:srgbClr val="CCCCCC"/>
-                </a:solidFill>
-                <a:latin typeface="Arial"/>
-                <a:ea typeface="Arial"/>
-                <a:cs typeface="Arial"/>
-              </a:defRPr>
-            </a:lvl8pPr>
-            <a:lvl9pPr>
-              <a:defRPr sz="1350">
-                <a:solidFill>
-                  <a:srgbClr val="CCCCCC"/>
-                </a:solidFill>
-                <a:latin typeface="Arial"/>
-                <a:ea typeface="Arial"/>
-                <a:cs typeface="Arial"/>
-              </a:defRPr>
-            </a:lvl9pPr>
-          </a:lstStyle>
-          <a:p xmlns:a="http://schemas.openxmlformats.org/drawingml/2006/main">
-            <a:pPr marL="0" indent="0">
-              <a:lnSpc>
-                <a:spcPct val="112000"/>
-              </a:lnSpc>
-              <a:spcBef>
-                <a:spcPts val="0"/>
-              </a:spcBef>
-              <a:spcAft>
-                <a:spcPts val="0"/>
-              </a:spcAft>
-              <a:buNone/>
-              <a:defRPr sz="1350">
-                <a:solidFill>
-                  <a:srgbClr val="CCCCCC"/>
-                </a:solidFill>
-                <a:latin typeface="Arial"/>
-                <a:ea typeface="Arial"/>
-                <a:cs typeface="Arial"/>
-              </a:defRPr>
-            </a:pPr>
-            <a:r>
-              <a:rPr sz="1350">
-                <a:solidFill>
-                  <a:srgbClr val="CCCCCC"/>
-                </a:solidFill>
-                <a:latin typeface="Arial"/>
-                <a:ea typeface="Arial"/>
-                <a:cs typeface="Arial"/>
-              </a:rPr>
-              <a:t>Keep the chosen width explicit; C integer promotions do not automatically limit x &lt;&lt; 1 to 8 bits.</a:t>
-            </a:r>
-          </a:p>
-        </p:txBody>
-      </p:sp>
-    </p:spTree>
-    <p:extLst>
-      <p:ext uri="{BB962C8B-B14F-4D97-AF65-F5344CB8AC3E}">
-        <p14:creationId xmlns:p14="http://schemas.microsoft.com/office/powerpoint/2010/main" val="3667182145"/>
-      </p:ext>
-    </p:extLst>
-  </p:cSld>
-</p:sld>
-</file>
-
-<file path=ppt/slides/slide22.xml><?xml version="1.0" encoding="utf-8"?>
-<p:sld xmlns:p="http://schemas.openxmlformats.org/presentationml/2006/main">
-  <p:cSld>
-    <p:spTree>
-      <p:nvGrpSpPr>
-        <p:cNvPr id="1" name=""/>
-        <p:cNvGrpSpPr/>
-        <p:nvPr/>
-      </p:nvGrpSpPr>
-      <p:grpSpPr>
-        <a:xfrm xmlns:a="http://schemas.openxmlformats.org/drawingml/2006/main"/>
-      </p:grpSpPr>
-      <p:sp>
-        <p:nvSpPr>
-          <p:cNvPr id="3" name="Footer Placeholder 2">
-            <a:extLst xmlns:a="http://schemas.openxmlformats.org/drawingml/2006/main">
-              <a:ext uri="{FF2B5EF4-FFF2-40B4-BE49-F238E27FC236}">
-                <a16:creationId xmlns:a16="http://schemas.microsoft.com/office/drawing/2014/main" id="{39EA4C82-C623-0196-4A95-876ADF5DEE92}"/>
-              </a:ext>
-            </a:extLst>
-          </p:cNvPr>
-          <p:cNvSpPr>
-            <a:spLocks xmlns:a="http://schemas.openxmlformats.org/drawingml/2006/main" noGrp="1"/>
-          </p:cNvSpPr>
-          <p:nvPr>
-            <p:ph type="ftr" idx="3"/>
-          </p:nvPr>
-        </p:nvSpPr>
-        <p:spPr>
-          <a:xfrm xmlns:a="http://schemas.openxmlformats.org/drawingml/2006/main">
-            <a:off x="393700" y="6279952"/>
-            <a:ext cx="3568700" cy="241240"/>
-          </a:xfrm>
-        </p:spPr>
-        <p:txBody>
-          <a:bodyPr xmlns:a="http://schemas.openxmlformats.org/drawingml/2006/main" lIns="0" tIns="0" rIns="0" bIns="0" anchor="t">
-            <a:noAutofit/>
-          </a:bodyPr>
-          <a:lstStyle xmlns:a="http://schemas.openxmlformats.org/drawingml/2006/main">
-            <a:defPPr>
-              <a:defRPr sz="1125">
-                <a:solidFill>
-                  <a:srgbClr val="FFFFFF"/>
-                </a:solidFill>
-                <a:latin typeface="Arial"/>
-                <a:ea typeface="Arial"/>
-                <a:cs typeface="Arial"/>
-              </a:defRPr>
-            </a:defPPr>
-            <a:lvl1pPr>
-              <a:defRPr sz="1125">
-                <a:solidFill>
-                  <a:srgbClr val="FFFFFF"/>
-                </a:solidFill>
-                <a:latin typeface="Arial"/>
-                <a:ea typeface="Arial"/>
-                <a:cs typeface="Arial"/>
-              </a:defRPr>
-            </a:lvl1pPr>
-            <a:lvl2pPr>
-              <a:defRPr sz="1125">
-                <a:solidFill>
-                  <a:srgbClr val="FFFFFF"/>
-                </a:solidFill>
-                <a:latin typeface="Arial"/>
-                <a:ea typeface="Arial"/>
-                <a:cs typeface="Arial"/>
-              </a:defRPr>
-            </a:lvl2pPr>
-            <a:lvl3pPr>
-              <a:defRPr sz="1125">
-                <a:solidFill>
-                  <a:srgbClr val="FFFFFF"/>
-                </a:solidFill>
-                <a:latin typeface="Arial"/>
-                <a:ea typeface="Arial"/>
-                <a:cs typeface="Arial"/>
-              </a:defRPr>
-            </a:lvl3pPr>
-            <a:lvl4pPr>
-              <a:defRPr sz="1125">
-                <a:solidFill>
-                  <a:srgbClr val="FFFFFF"/>
-                </a:solidFill>
-                <a:latin typeface="Arial"/>
-                <a:ea typeface="Arial"/>
-                <a:cs typeface="Arial"/>
-              </a:defRPr>
-            </a:lvl4pPr>
-            <a:lvl5pPr>
-              <a:defRPr sz="1125">
-                <a:solidFill>
-                  <a:srgbClr val="FFFFFF"/>
-                </a:solidFill>
-                <a:latin typeface="Arial"/>
-                <a:ea typeface="Arial"/>
-                <a:cs typeface="Arial"/>
-              </a:defRPr>
-            </a:lvl5pPr>
-            <a:lvl6pPr>
-              <a:defRPr sz="1125">
-                <a:solidFill>
-                  <a:srgbClr val="FFFFFF"/>
-                </a:solidFill>
-                <a:latin typeface="Arial"/>
-                <a:ea typeface="Arial"/>
-                <a:cs typeface="Arial"/>
-              </a:defRPr>
-            </a:lvl6pPr>
-            <a:lvl7pPr>
-              <a:defRPr sz="1125">
-                <a:solidFill>
-                  <a:srgbClr val="FFFFFF"/>
-                </a:solidFill>
-                <a:latin typeface="Arial"/>
-                <a:ea typeface="Arial"/>
-                <a:cs typeface="Arial"/>
-              </a:defRPr>
-            </a:lvl7pPr>
-            <a:lvl8pPr>
-              <a:defRPr sz="1125">
-                <a:solidFill>
-                  <a:srgbClr val="FFFFFF"/>
-                </a:solidFill>
-                <a:latin typeface="Arial"/>
-                <a:ea typeface="Arial"/>
-                <a:cs typeface="Arial"/>
-              </a:defRPr>
-            </a:lvl8pPr>
-            <a:lvl9pPr>
-              <a:defRPr sz="1125">
-                <a:solidFill>
-                  <a:srgbClr val="FFFFFF"/>
-                </a:solidFill>
-                <a:latin typeface="Arial"/>
-                <a:ea typeface="Arial"/>
-                <a:cs typeface="Arial"/>
-              </a:defRPr>
-            </a:lvl9pPr>
-          </a:lstStyle>
-          <a:p xmlns:a="http://schemas.openxmlformats.org/drawingml/2006/main">
-            <a:pPr marL="0" indent="0">
-              <a:lnSpc>
-                <a:spcPct val="112000"/>
-              </a:lnSpc>
-              <a:spcBef>
-                <a:spcPts val="0"/>
-              </a:spcBef>
-              <a:spcAft>
-                <a:spcPts val="0"/>
-              </a:spcAft>
-              <a:buNone/>
-              <a:defRPr sz="1125">
-                <a:solidFill>
-                  <a:srgbClr val="FFFFFF"/>
-                </a:solidFill>
-                <a:latin typeface="Arial"/>
-                <a:ea typeface="Arial"/>
-                <a:cs typeface="Arial"/>
-              </a:defRPr>
-            </a:pPr>
-            <a:r>
-              <a:rPr sz="1125">
-                <a:solidFill>
-                  <a:srgbClr val="FFFFFF"/>
-                </a:solidFill>
-                <a:latin typeface="Arial"/>
-                <a:ea typeface="Arial"/>
-                <a:cs typeface="Arial"/>
-              </a:rPr>
-              <a:t>CS 211 · Recitation 07</a:t>
-            </a:r>
-          </a:p>
-        </p:txBody>
-      </p:sp>
-      <p:sp>
-        <p:nvSpPr>
-          <p:cNvPr id="532" name="Google Shape;532;p58">
-            <a:extLst xmlns:a="http://schemas.openxmlformats.org/drawingml/2006/main">
-              <a:ext uri="{FF2B5EF4-FFF2-40B4-BE49-F238E27FC236}">
-                <a16:creationId xmlns:a16="http://schemas.microsoft.com/office/drawing/2014/main" id="{1BCBE750-7048-686D-1472-52C53362D6CD}"/>
-              </a:ext>
-            </a:extLst>
-          </p:cNvPr>
-          <p:cNvSpPr>
-            <a:spLocks xmlns:a="http://schemas.openxmlformats.org/drawingml/2006/main" noGrp="1"/>
-          </p:cNvSpPr>
-          <p:nvPr>
-            <p:ph type="sldNum" idx="4"/>
-          </p:nvPr>
-        </p:nvSpPr>
-        <p:spPr>
-          <a:xfrm xmlns:a="http://schemas.openxmlformats.org/drawingml/2006/main">
-            <a:off x="11279332" y="6279294"/>
-            <a:ext cx="518968" cy="241240"/>
-          </a:xfrm>
-        </p:spPr>
-        <p:txBody>
-          <a:bodyPr xmlns:a="http://schemas.openxmlformats.org/drawingml/2006/main" spcFirstLastPara="1" vert="horz" wrap="square" lIns="0" tIns="0" rIns="0" bIns="0" anchor="t">
-            <a:noAutofit/>
-          </a:bodyPr>
-          <a:lstStyle xmlns:a="http://schemas.openxmlformats.org/drawingml/2006/main">
-            <a:defPPr>
-              <a:defRPr sz="1125">
-                <a:solidFill>
-                  <a:srgbClr val="FFFFFF"/>
-                </a:solidFill>
-                <a:latin typeface="Arial"/>
-                <a:ea typeface="Arial"/>
-                <a:cs typeface="Arial"/>
-              </a:defRPr>
-            </a:defPPr>
-            <a:lvl1pPr>
-              <a:defRPr sz="1125">
-                <a:solidFill>
-                  <a:srgbClr val="FFFFFF"/>
-                </a:solidFill>
-                <a:latin typeface="Arial"/>
-                <a:ea typeface="Arial"/>
-                <a:cs typeface="Arial"/>
-              </a:defRPr>
-            </a:lvl1pPr>
-            <a:lvl2pPr>
-              <a:defRPr sz="1125">
-                <a:solidFill>
-                  <a:srgbClr val="FFFFFF"/>
-                </a:solidFill>
-                <a:latin typeface="Arial"/>
-                <a:ea typeface="Arial"/>
-                <a:cs typeface="Arial"/>
-              </a:defRPr>
-            </a:lvl2pPr>
-            <a:lvl3pPr>
-              <a:defRPr sz="1125">
-                <a:solidFill>
-                  <a:srgbClr val="FFFFFF"/>
-                </a:solidFill>
-                <a:latin typeface="Arial"/>
-                <a:ea typeface="Arial"/>
-                <a:cs typeface="Arial"/>
-              </a:defRPr>
-            </a:lvl3pPr>
-            <a:lvl4pPr>
-              <a:defRPr sz="1125">
-                <a:solidFill>
-                  <a:srgbClr val="FFFFFF"/>
-                </a:solidFill>
-                <a:latin typeface="Arial"/>
-                <a:ea typeface="Arial"/>
-                <a:cs typeface="Arial"/>
-              </a:defRPr>
-            </a:lvl4pPr>
-            <a:lvl5pPr>
-              <a:defRPr sz="1125">
-                <a:solidFill>
-                  <a:srgbClr val="FFFFFF"/>
-                </a:solidFill>
-                <a:latin typeface="Arial"/>
-                <a:ea typeface="Arial"/>
-                <a:cs typeface="Arial"/>
-              </a:defRPr>
-            </a:lvl5pPr>
-            <a:lvl6pPr>
-              <a:defRPr sz="1125">
-                <a:solidFill>
-                  <a:srgbClr val="FFFFFF"/>
-                </a:solidFill>
-                <a:latin typeface="Arial"/>
-                <a:ea typeface="Arial"/>
-                <a:cs typeface="Arial"/>
-              </a:defRPr>
-            </a:lvl6pPr>
-            <a:lvl7pPr>
-              <a:defRPr sz="1125">
-                <a:solidFill>
-                  <a:srgbClr val="FFFFFF"/>
-                </a:solidFill>
-                <a:latin typeface="Arial"/>
-                <a:ea typeface="Arial"/>
-                <a:cs typeface="Arial"/>
-              </a:defRPr>
-            </a:lvl7pPr>
-            <a:lvl8pPr>
-              <a:defRPr sz="1125">
-                <a:solidFill>
-                  <a:srgbClr val="FFFFFF"/>
-                </a:solidFill>
-                <a:latin typeface="Arial"/>
-                <a:ea typeface="Arial"/>
-                <a:cs typeface="Arial"/>
-              </a:defRPr>
-            </a:lvl8pPr>
-            <a:lvl9pPr>
-              <a:defRPr sz="1125">
-                <a:solidFill>
-                  <a:srgbClr val="FFFFFF"/>
-                </a:solidFill>
-                <a:latin typeface="Arial"/>
-                <a:ea typeface="Arial"/>
-                <a:cs typeface="Arial"/>
-              </a:defRPr>
-            </a:lvl9pPr>
-          </a:lstStyle>
-          <a:p xmlns:a="http://schemas.openxmlformats.org/drawingml/2006/main">
-            <a:pPr marL="0" indent="0">
-              <a:lnSpc>
-                <a:spcPct val="112000"/>
-              </a:lnSpc>
-              <a:spcBef>
-                <a:spcPts val="0"/>
-              </a:spcBef>
-              <a:spcAft>
-                <a:spcPts val="0"/>
-              </a:spcAft>
-              <a:buNone/>
-              <a:defRPr sz="1125">
-                <a:solidFill>
-                  <a:srgbClr val="FFFFFF"/>
-                </a:solidFill>
-                <a:latin typeface="Arial"/>
-                <a:ea typeface="Arial"/>
-                <a:cs typeface="Arial"/>
-              </a:defRPr>
-            </a:pPr>
-            <a:r>
-              <a:rPr sz="1125">
-                <a:solidFill>
-                  <a:srgbClr val="FFFFFF"/>
-                </a:solidFill>
-                <a:latin typeface="Arial"/>
-                <a:ea typeface="Arial"/>
-                <a:cs typeface="Arial"/>
-              </a:rPr>
-              <a:t>22</a:t>
-            </a:r>
-          </a:p>
-        </p:txBody>
-      </p:sp>
-      <p:sp>
-        <p:nvSpPr>
-          <p:cNvPr id="533" name="Google Shape;533;p58">
-            <a:extLst xmlns:a="http://schemas.openxmlformats.org/drawingml/2006/main">
-              <a:ext uri="{FF2B5EF4-FFF2-40B4-BE49-F238E27FC236}">
-                <a16:creationId xmlns:a16="http://schemas.microsoft.com/office/drawing/2014/main" id="{1B5D55CD-1C17-7CD8-F26A-2DD65B067687}"/>
-              </a:ext>
-            </a:extLst>
-          </p:cNvPr>
-          <p:cNvSpPr>
-            <a:spLocks xmlns:a="http://schemas.openxmlformats.org/drawingml/2006/main" noGrp="1"/>
-          </p:cNvSpPr>
-          <p:nvPr>
-            <p:ph type="title" idx="0"/>
-          </p:nvPr>
-        </p:nvSpPr>
-        <p:spPr>
-          <a:xfrm xmlns:a="http://schemas.openxmlformats.org/drawingml/2006/main">
-            <a:off x="393700" y="344008"/>
-            <a:ext cx="11404600" cy="1047491"/>
-          </a:xfrm>
-        </p:spPr>
-        <p:txBody>
-          <a:bodyPr xmlns:a="http://schemas.openxmlformats.org/drawingml/2006/main" spcFirstLastPara="1" vert="horz" wrap="square" lIns="0" tIns="0" rIns="0" bIns="0" anchor="t">
-            <a:noAutofit/>
-          </a:bodyPr>
-          <a:lstStyle xmlns:a="http://schemas.openxmlformats.org/drawingml/2006/main">
-            <a:defPPr>
-              <a:defRPr sz="3150">
-                <a:solidFill>
-                  <a:srgbClr val="FFFFFF"/>
-                </a:solidFill>
-                <a:latin typeface="Arial"/>
-                <a:ea typeface="Arial"/>
-                <a:cs typeface="Arial"/>
-              </a:defRPr>
-            </a:defPPr>
-            <a:lvl1pPr>
-              <a:defRPr sz="3150">
-                <a:solidFill>
-                  <a:srgbClr val="FFFFFF"/>
-                </a:solidFill>
-                <a:latin typeface="Arial"/>
-                <a:ea typeface="Arial"/>
-                <a:cs typeface="Arial"/>
-              </a:defRPr>
-            </a:lvl1pPr>
-            <a:lvl2pPr>
-              <a:defRPr sz="3150">
-                <a:solidFill>
-                  <a:srgbClr val="FFFFFF"/>
-                </a:solidFill>
-                <a:latin typeface="Arial"/>
-                <a:ea typeface="Arial"/>
-                <a:cs typeface="Arial"/>
-              </a:defRPr>
-            </a:lvl2pPr>
-            <a:lvl3pPr>
-              <a:defRPr sz="3150">
-                <a:solidFill>
-                  <a:srgbClr val="FFFFFF"/>
-                </a:solidFill>
-                <a:latin typeface="Arial"/>
-                <a:ea typeface="Arial"/>
-                <a:cs typeface="Arial"/>
-              </a:defRPr>
-            </a:lvl3pPr>
-            <a:lvl4pPr>
-              <a:defRPr sz="3150">
-                <a:solidFill>
-                  <a:srgbClr val="FFFFFF"/>
-                </a:solidFill>
-                <a:latin typeface="Arial"/>
-                <a:ea typeface="Arial"/>
-                <a:cs typeface="Arial"/>
-              </a:defRPr>
-            </a:lvl4pPr>
-            <a:lvl5pPr>
-              <a:defRPr sz="3150">
-                <a:solidFill>
-                  <a:srgbClr val="FFFFFF"/>
-                </a:solidFill>
-                <a:latin typeface="Arial"/>
-                <a:ea typeface="Arial"/>
-                <a:cs typeface="Arial"/>
-              </a:defRPr>
-            </a:lvl5pPr>
-            <a:lvl6pPr>
-              <a:defRPr sz="3150">
-                <a:solidFill>
-                  <a:srgbClr val="FFFFFF"/>
-                </a:solidFill>
-                <a:latin typeface="Arial"/>
-                <a:ea typeface="Arial"/>
-                <a:cs typeface="Arial"/>
-              </a:defRPr>
-            </a:lvl6pPr>
-            <a:lvl7pPr>
-              <a:defRPr sz="3150">
-                <a:solidFill>
-                  <a:srgbClr val="FFFFFF"/>
-                </a:solidFill>
-                <a:latin typeface="Arial"/>
-                <a:ea typeface="Arial"/>
-                <a:cs typeface="Arial"/>
-              </a:defRPr>
-            </a:lvl7pPr>
-            <a:lvl8pPr>
-              <a:defRPr sz="3150">
-                <a:solidFill>
-                  <a:srgbClr val="FFFFFF"/>
-                </a:solidFill>
-                <a:latin typeface="Arial"/>
-                <a:ea typeface="Arial"/>
-                <a:cs typeface="Arial"/>
-              </a:defRPr>
-            </a:lvl8pPr>
-            <a:lvl9pPr>
-              <a:defRPr sz="3150">
-                <a:solidFill>
-                  <a:srgbClr val="FFFFFF"/>
-                </a:solidFill>
-                <a:latin typeface="Arial"/>
-                <a:ea typeface="Arial"/>
-                <a:cs typeface="Arial"/>
-              </a:defRPr>
-            </a:lvl9pPr>
-          </a:lstStyle>
-          <a:p xmlns:a="http://schemas.openxmlformats.org/drawingml/2006/main">
-            <a:pPr marL="0" indent="0">
-              <a:lnSpc>
-                <a:spcPct val="112000"/>
-              </a:lnSpc>
-              <a:spcBef>
-                <a:spcPts val="0"/>
-              </a:spcBef>
-              <a:spcAft>
-                <a:spcPts val="0"/>
-              </a:spcAft>
-              <a:buNone/>
-              <a:defRPr sz="3150">
-                <a:solidFill>
-                  <a:srgbClr val="FFFFFF"/>
-                </a:solidFill>
-                <a:latin typeface="Arial"/>
-                <a:ea typeface="Arial"/>
-                <a:cs typeface="Arial"/>
-              </a:defRPr>
-            </a:pPr>
-            <a:r>
-              <a:rPr sz="3150">
-                <a:solidFill>
-                  <a:srgbClr val="FFFFFF"/>
-                </a:solidFill>
-                <a:latin typeface="Arial"/>
-                <a:ea typeface="Arial"/>
-                <a:cs typeface="Arial"/>
-              </a:rPr>
-              <a:t>Build a truth table one gate at a time</a:t>
-            </a:r>
-          </a:p>
-        </p:txBody>
-      </p:sp>
-      <p:sp>
-        <p:nvSpPr>
-          <p:cNvPr id="7" name="Google Shape;534;p58">
-            <a:extLst xmlns:a="http://schemas.openxmlformats.org/drawingml/2006/main">
-              <a:ext uri="{FF2B5EF4-FFF2-40B4-BE49-F238E27FC236}">
-                <a16:creationId xmlns:a16="http://schemas.microsoft.com/office/drawing/2014/main" id="{3A923FEE-B8D2-CD3A-ABBD-21770B40AA24}"/>
-              </a:ext>
-            </a:extLst>
-          </p:cNvPr>
-          <p:cNvSpPr>
-            <a:spLocks xmlns:a="http://schemas.openxmlformats.org/drawingml/2006/main" noGrp="1"/>
-          </p:cNvSpPr>
-          <p:nvPr/>
-        </p:nvSpPr>
-        <p:spPr>
-          <a:xfrm xmlns:a="http://schemas.openxmlformats.org/drawingml/2006/main">
-            <a:off x="393700" y="2031999"/>
-            <a:ext cx="5537200" cy="3534787"/>
-          </a:xfrm>
-          <a:prstGeom xmlns:a="http://schemas.openxmlformats.org/drawingml/2006/main" prst="rect">
-            <a:avLst/>
-          </a:prstGeom>
-        </p:spPr>
-        <p:txBody>
-          <a:bodyPr xmlns:a="http://schemas.openxmlformats.org/drawingml/2006/main" spcFirstLastPara="1" vert="horz" wrap="square" lIns="0" tIns="0" rIns="0" bIns="0" anchor="t">
-            <a:noAutofit/>
-          </a:bodyPr>
-          <a:lstStyle xmlns:a="http://schemas.openxmlformats.org/drawingml/2006/main">
-            <a:defPPr>
-              <a:defRPr sz="1875">
-                <a:solidFill>
-                  <a:srgbClr val="FFFFFF"/>
-                </a:solidFill>
-                <a:latin typeface="Arial"/>
-                <a:ea typeface="Arial"/>
-                <a:cs typeface="Arial"/>
-              </a:defRPr>
-            </a:defPPr>
-            <a:lvl1pPr marL="228600" indent="-228600" algn="l" defTabSz="914400">
-              <a:lnSpc>
-                <a:spcPct val="90000"/>
-              </a:lnSpc>
-              <a:spcBef>
-                <a:spcPts val="1000"/>
-              </a:spcBef>
-              <a:buFont typeface="Arial"/>
-              <a:buChar char="•"/>
-              <a:defRPr sz="2400" kern="1200">
-                <a:solidFill>
-                  <a:schemeClr val="tx1"/>
-                </a:solidFill>
-                <a:latin typeface="+mn-lt"/>
-                <a:ea typeface="+mn-lt"/>
-                <a:cs typeface="+mn-lt"/>
-              </a:defRPr>
-            </a:lvl1pPr>
-            <a:lvl2pPr marL="685800" indent="-228600" algn="l" defTabSz="914400">
-              <a:lnSpc>
-                <a:spcPct val="90000"/>
-              </a:lnSpc>
-              <a:spcBef>
-                <a:spcPts val="500"/>
-              </a:spcBef>
-              <a:buFont typeface="Arial"/>
-              <a:buChar char="•"/>
-              <a:defRPr sz="2000" kern="1200">
-                <a:solidFill>
-                  <a:schemeClr val="tx1"/>
-                </a:solidFill>
-                <a:latin typeface="+mn-lt"/>
-                <a:ea typeface="+mn-lt"/>
-                <a:cs typeface="+mn-lt"/>
-              </a:defRPr>
-            </a:lvl2pPr>
-            <a:lvl3pPr marL="1143000" indent="-228600" algn="l" defTabSz="914400">
-              <a:lnSpc>
-                <a:spcPct val="90000"/>
-              </a:lnSpc>
-              <a:spcBef>
-                <a:spcPts val="500"/>
-              </a:spcBef>
-              <a:buFont typeface="Arial"/>
-              <a:buChar char="•"/>
-              <a:defRPr sz="1800" kern="1200">
-                <a:solidFill>
-                  <a:schemeClr val="tx1"/>
-                </a:solidFill>
-                <a:latin typeface="+mn-lt"/>
-                <a:ea typeface="+mn-lt"/>
-                <a:cs typeface="+mn-lt"/>
-              </a:defRPr>
-            </a:lvl3pPr>
-            <a:lvl4pPr marL="1600200" indent="-228600" algn="l" defTabSz="914400">
-              <a:lnSpc>
-                <a:spcPct val="90000"/>
-              </a:lnSpc>
-              <a:spcBef>
-                <a:spcPts val="500"/>
-              </a:spcBef>
-              <a:buFont typeface="Arial"/>
-              <a:buChar char="•"/>
-              <a:defRPr sz="1800" kern="1200">
-                <a:solidFill>
-                  <a:schemeClr val="tx1"/>
-                </a:solidFill>
-                <a:latin typeface="+mn-lt"/>
-                <a:ea typeface="+mn-lt"/>
-                <a:cs typeface="+mn-lt"/>
-              </a:defRPr>
-            </a:lvl4pPr>
-            <a:lvl5pPr marL="2057400" indent="-228600" algn="l" defTabSz="914400">
-              <a:lnSpc>
-                <a:spcPct val="90000"/>
-              </a:lnSpc>
-              <a:spcBef>
-                <a:spcPts val="500"/>
-              </a:spcBef>
-              <a:buFont typeface="Arial"/>
-              <a:buChar char="•"/>
-              <a:defRPr sz="1800" kern="1200">
-                <a:solidFill>
-                  <a:schemeClr val="tx1"/>
-                </a:solidFill>
-                <a:latin typeface="+mn-lt"/>
-                <a:ea typeface="+mn-lt"/>
-                <a:cs typeface="+mn-lt"/>
-              </a:defRPr>
-            </a:lvl5pPr>
-            <a:lvl6pPr marL="2514600" indent="-228600" algn="l" defTabSz="914400">
-              <a:lnSpc>
-                <a:spcPct val="90000"/>
-              </a:lnSpc>
-              <a:spcBef>
-                <a:spcPts val="500"/>
-              </a:spcBef>
-              <a:buFont typeface="Arial"/>
-              <a:buChar char="•"/>
-              <a:defRPr sz="1800" kern="1200">
-                <a:solidFill>
-                  <a:schemeClr val="tx1"/>
-                </a:solidFill>
-                <a:latin typeface="+mn-lt"/>
-                <a:ea typeface="+mn-lt"/>
-                <a:cs typeface="+mn-lt"/>
-              </a:defRPr>
-            </a:lvl6pPr>
-            <a:lvl7pPr marL="2971800" indent="-228600" algn="l" defTabSz="914400">
-              <a:lnSpc>
-                <a:spcPct val="90000"/>
-              </a:lnSpc>
-              <a:spcBef>
-                <a:spcPts val="500"/>
-              </a:spcBef>
-              <a:buFont typeface="Arial"/>
-              <a:buChar char="•"/>
-              <a:defRPr sz="1800" kern="1200">
-                <a:solidFill>
-                  <a:schemeClr val="tx1"/>
-                </a:solidFill>
-                <a:latin typeface="+mn-lt"/>
-                <a:ea typeface="+mn-lt"/>
-                <a:cs typeface="+mn-lt"/>
-              </a:defRPr>
-            </a:lvl7pPr>
-            <a:lvl8pPr marL="3429000" indent="-228600" algn="l" defTabSz="914400">
-              <a:lnSpc>
-                <a:spcPct val="90000"/>
-              </a:lnSpc>
-              <a:spcBef>
-                <a:spcPts val="500"/>
-              </a:spcBef>
-              <a:buFont typeface="Arial"/>
-              <a:buChar char="•"/>
-              <a:defRPr sz="1800" kern="1200">
-                <a:solidFill>
-                  <a:schemeClr val="tx1"/>
-                </a:solidFill>
-                <a:latin typeface="+mn-lt"/>
-                <a:ea typeface="+mn-lt"/>
-                <a:cs typeface="+mn-lt"/>
-              </a:defRPr>
-            </a:lvl8pPr>
-            <a:lvl9pPr marL="3886200" indent="-228600" algn="l" defTabSz="914400">
-              <a:lnSpc>
-                <a:spcPct val="90000"/>
-              </a:lnSpc>
-              <a:spcBef>
-                <a:spcPts val="500"/>
-              </a:spcBef>
-              <a:buFont typeface="Arial"/>
-              <a:buChar char="•"/>
-              <a:defRPr sz="1800" kern="1200">
-                <a:solidFill>
-                  <a:schemeClr val="tx1"/>
-                </a:solidFill>
-                <a:latin typeface="+mn-lt"/>
-                <a:ea typeface="+mn-lt"/>
-                <a:cs typeface="+mn-lt"/>
-              </a:defRPr>
-            </a:lvl9pPr>
-          </a:lstStyle>
-          <a:p xmlns:a="http://schemas.openxmlformats.org/drawingml/2006/main">
-            <a:pPr marL="0" indent="0">
-              <a:lnSpc>
-                <a:spcPct val="112000"/>
-              </a:lnSpc>
-              <a:spcBef>
-                <a:spcPts val="0"/>
-              </a:spcBef>
-              <a:spcAft>
-                <a:spcPts val="0"/>
-              </a:spcAft>
-              <a:buNone/>
-              <a:defRPr sz="1875">
-                <a:solidFill>
-                  <a:srgbClr val="FFFFFF"/>
-                </a:solidFill>
-                <a:latin typeface="Arial"/>
-                <a:ea typeface="Arial"/>
-                <a:cs typeface="Arial"/>
-              </a:defRPr>
-            </a:pPr>
-            <a:r>
-              <a:rPr sz="1875">
-                <a:solidFill>
-                  <a:srgbClr val="FFFFFF"/>
-                </a:solidFill>
-                <a:latin typeface="Arial"/>
-                <a:ea typeface="Arial"/>
-                <a:cs typeface="Arial"/>
-              </a:rPr>
               <a:t>Do not try to guess the entire circuit at once. Write a column for each intermediate result.</a:t>
             </a:r>
           </a:p>
@@ -28663,7 +27059,7 @@
           <p:cNvPr id="534" name="">
             <a:extLst xmlns:a="http://schemas.openxmlformats.org/drawingml/2006/main">
               <a:ext uri="{FF2B5EF4-FFF2-40B4-BE49-F238E27FC236}">
-                <a16:creationId xmlns:a16="http://schemas.microsoft.com/office/drawing/2014/main" id="{89013C81-78D9-4D92-AF05-E237CFA2DC9F}"/>
+                <a16:creationId xmlns:a16="http://schemas.microsoft.com/office/drawing/2014/main" id="{A012E9F3-5308-4C3A-9C19-7DE0AFD2C889}"/>
               </a:ext>
             </a:extLst>
           </p:cNvPr>
@@ -29664,7 +28060,7 @@
           <p:cNvPr id="535" name="Takeaway">
             <a:extLst xmlns:a="http://schemas.openxmlformats.org/drawingml/2006/main">
               <a:ext uri="{FF2B5EF4-FFF2-40B4-BE49-F238E27FC236}">
-                <a16:creationId xmlns:a16="http://schemas.microsoft.com/office/drawing/2014/main" id="{80E7B2F5-B15B-4346-B9E1-82DA41827297}"/>
+                <a16:creationId xmlns:a16="http://schemas.microsoft.com/office/drawing/2014/main" id="{525F78FC-4EDC-46D3-AC08-FC1461A3F460}"/>
               </a:ext>
             </a:extLst>
           </p:cNvPr>
@@ -29837,7 +28233,7 @@
 </p:sld>
 </file>
 
-<file path=ppt/slides/slide23.xml><?xml version="1.0" encoding="utf-8"?>
+<file path=ppt/slides/slide22.xml><?xml version="1.0" encoding="utf-8"?>
 <p:sld xmlns:p="http://schemas.openxmlformats.org/presentationml/2006/main">
   <p:cSld>
     <p:spTree>
@@ -30170,7 +28566,7 @@
                 <a:ea typeface="Arial"/>
                 <a:cs typeface="Arial"/>
               </a:rPr>
-              <a:t>23</a:t>
+              <a:t>22</a:t>
             </a:r>
           </a:p>
         </p:txBody>
@@ -31097,7 +29493,7 @@
           <p:cNvPr id="534" name="Takeaway">
             <a:extLst xmlns:a="http://schemas.openxmlformats.org/drawingml/2006/main">
               <a:ext uri="{FF2B5EF4-FFF2-40B4-BE49-F238E27FC236}">
-                <a16:creationId xmlns:a16="http://schemas.microsoft.com/office/drawing/2014/main" id="{ED900BF0-8FCE-4DC5-929A-57620050F0A2}"/>
+                <a16:creationId xmlns:a16="http://schemas.microsoft.com/office/drawing/2014/main" id="{CFACD00C-15FA-4ADC-B5AA-67413F22CBFF}"/>
               </a:ext>
             </a:extLst>
           </p:cNvPr>
@@ -32498,7 +30894,7 @@
           <p:cNvPr id="534" name="Takeaway">
             <a:extLst xmlns:a="http://schemas.openxmlformats.org/drawingml/2006/main">
               <a:ext uri="{FF2B5EF4-FFF2-40B4-BE49-F238E27FC236}">
-                <a16:creationId xmlns:a16="http://schemas.microsoft.com/office/drawing/2014/main" id="{93E96C14-84FF-4F4D-B462-2FB25CA11BBD}"/>
+                <a16:creationId xmlns:a16="http://schemas.microsoft.com/office/drawing/2014/main" id="{8E7FD6EA-DD8C-469E-A422-AC9457977B48}"/>
               </a:ext>
             </a:extLst>
           </p:cNvPr>
@@ -33914,7 +32310,7 @@
           <p:cNvPr id="534" name="Takeaway">
             <a:extLst xmlns:a="http://schemas.openxmlformats.org/drawingml/2006/main">
               <a:ext uri="{FF2B5EF4-FFF2-40B4-BE49-F238E27FC236}">
-                <a16:creationId xmlns:a16="http://schemas.microsoft.com/office/drawing/2014/main" id="{C6759121-7196-456C-9EED-108C886AEE21}"/>
+                <a16:creationId xmlns:a16="http://schemas.microsoft.com/office/drawing/2014/main" id="{37E8A624-1B8E-4E81-A102-E31049CA9299}"/>
               </a:ext>
             </a:extLst>
           </p:cNvPr>
@@ -35363,7 +33759,7 @@
           <p:cNvPr id="534" name="Takeaway">
             <a:extLst xmlns:a="http://schemas.openxmlformats.org/drawingml/2006/main">
               <a:ext uri="{FF2B5EF4-FFF2-40B4-BE49-F238E27FC236}">
-                <a16:creationId xmlns:a16="http://schemas.microsoft.com/office/drawing/2014/main" id="{7A41ED02-16A2-4943-A9A0-D2FC2D8A4863}"/>
+                <a16:creationId xmlns:a16="http://schemas.microsoft.com/office/drawing/2014/main" id="{E948C928-12C4-4381-A325-E7F56B1B2A08}"/>
               </a:ext>
             </a:extLst>
           </p:cNvPr>
@@ -36746,7 +35142,7 @@
           <p:cNvPr id="534" name="Takeaway">
             <a:extLst xmlns:a="http://schemas.openxmlformats.org/drawingml/2006/main">
               <a:ext uri="{FF2B5EF4-FFF2-40B4-BE49-F238E27FC236}">
-                <a16:creationId xmlns:a16="http://schemas.microsoft.com/office/drawing/2014/main" id="{70053DA7-F09D-4570-847F-32397D0C0051}"/>
+                <a16:creationId xmlns:a16="http://schemas.microsoft.com/office/drawing/2014/main" id="{9DC7F8A1-CD71-43C2-AAC8-6D5E7417A9CE}"/>
               </a:ext>
             </a:extLst>
           </p:cNvPr>
@@ -38162,7 +36558,7 @@
           <p:cNvPr id="534" name="Takeaway">
             <a:extLst xmlns:a="http://schemas.openxmlformats.org/drawingml/2006/main">
               <a:ext uri="{FF2B5EF4-FFF2-40B4-BE49-F238E27FC236}">
-                <a16:creationId xmlns:a16="http://schemas.microsoft.com/office/drawing/2014/main" id="{B351121F-963A-41AF-9926-D6A656F8F5CE}"/>
+                <a16:creationId xmlns:a16="http://schemas.microsoft.com/office/drawing/2014/main" id="{32666288-B351-4C6A-BB14-A72BD39F5A15}"/>
               </a:ext>
             </a:extLst>
           </p:cNvPr>
@@ -39579,7 +37975,7 @@
           <p:cNvPr id="534" name="Takeaway">
             <a:extLst xmlns:a="http://schemas.openxmlformats.org/drawingml/2006/main">
               <a:ext uri="{FF2B5EF4-FFF2-40B4-BE49-F238E27FC236}">
-                <a16:creationId xmlns:a16="http://schemas.microsoft.com/office/drawing/2014/main" id="{5ED3F4BE-38B6-4980-9309-D1E6087DBA1E}"/>
+                <a16:creationId xmlns:a16="http://schemas.microsoft.com/office/drawing/2014/main" id="{2D81D9CD-6125-4C20-8EBE-680FD8464A5B}"/>
               </a:ext>
             </a:extLst>
           </p:cNvPr>
@@ -41078,7 +39474,7 @@
           <p:cNvPr id="534" name="Takeaway">
             <a:extLst xmlns:a="http://schemas.openxmlformats.org/drawingml/2006/main">
               <a:ext uri="{FF2B5EF4-FFF2-40B4-BE49-F238E27FC236}">
-                <a16:creationId xmlns:a16="http://schemas.microsoft.com/office/drawing/2014/main" id="{C4F297A4-0022-447E-B6ED-41A7D723F31A}"/>
+                <a16:creationId xmlns:a16="http://schemas.microsoft.com/office/drawing/2014/main" id="{ECC071D2-F7D0-45B7-98CD-046A82AB859D}"/>
               </a:ext>
             </a:extLst>
           </p:cNvPr>

</xml_diff>

<commit_message>
Trim lookahead explanation from adder answer
</commit_message>
<xml_diff>
--- a/public/presentations/CS211_Recitation_7.pptx
+++ b/public/presentations/CS211_Recitation_7.pptx
@@ -2,44 +2,44 @@
 <file path=ppt/presentation.xml><?xml version="1.0" encoding="utf-8"?>
 <p:presentation xmlns:p="http://schemas.openxmlformats.org/presentationml/2006/main" embedTrueTypeFonts="1" saveSubsetFonts="0">
   <p:sldMasterIdLst>
-    <p:sldMasterId xmlns:r="http://schemas.openxmlformats.org/officeDocument/2006/relationships" id="2147483648" r:id="Rce25d4b090c14cc1"/>
+    <p:sldMasterId xmlns:r="http://schemas.openxmlformats.org/officeDocument/2006/relationships" id="2147483648" r:id="R37655bd99d084677"/>
   </p:sldMasterIdLst>
   <p:notesMasterIdLst>
-    <p:notesMasterId xmlns:r="http://schemas.openxmlformats.org/officeDocument/2006/relationships" r:id="R3d8ab4d9cfa54910"/>
+    <p:notesMasterId xmlns:r="http://schemas.openxmlformats.org/officeDocument/2006/relationships" r:id="R03256266da544236"/>
   </p:notesMasterIdLst>
   <p:sldIdLst>
-    <p:sldId xmlns:r="http://schemas.openxmlformats.org/officeDocument/2006/relationships" id="256" r:id="R8dab3aaf10494ca6"/>
-    <p:sldId xmlns:r="http://schemas.openxmlformats.org/officeDocument/2006/relationships" id="257" r:id="R7d5ccc01832541e8"/>
-    <p:sldId xmlns:r="http://schemas.openxmlformats.org/officeDocument/2006/relationships" id="258" r:id="Rdf206e1b5c68413b"/>
-    <p:sldId xmlns:r="http://schemas.openxmlformats.org/officeDocument/2006/relationships" id="259" r:id="Rc6a9ea1ad4234004"/>
-    <p:sldId xmlns:r="http://schemas.openxmlformats.org/officeDocument/2006/relationships" id="260" r:id="R213f2f324d604ecf"/>
-    <p:sldId xmlns:r="http://schemas.openxmlformats.org/officeDocument/2006/relationships" id="261" r:id="R994f085237324869"/>
-    <p:sldId xmlns:r="http://schemas.openxmlformats.org/officeDocument/2006/relationships" id="262" r:id="Rb547301698ae4e18"/>
-    <p:sldId xmlns:r="http://schemas.openxmlformats.org/officeDocument/2006/relationships" id="263" r:id="Rf4491fe6e9824604"/>
-    <p:sldId xmlns:r="http://schemas.openxmlformats.org/officeDocument/2006/relationships" id="264" r:id="R4aaa9c64e6b64cf5"/>
-    <p:sldId xmlns:r="http://schemas.openxmlformats.org/officeDocument/2006/relationships" id="265" r:id="R237a5bce76e04972"/>
-    <p:sldId xmlns:r="http://schemas.openxmlformats.org/officeDocument/2006/relationships" id="266" r:id="R23e43d821d4c46c4"/>
-    <p:sldId xmlns:r="http://schemas.openxmlformats.org/officeDocument/2006/relationships" id="267" r:id="R22cfc8b47f234451"/>
-    <p:sldId xmlns:r="http://schemas.openxmlformats.org/officeDocument/2006/relationships" id="268" r:id="Rad941524ed7249c8"/>
-    <p:sldId xmlns:r="http://schemas.openxmlformats.org/officeDocument/2006/relationships" id="269" r:id="Rfa68cad13ed94f25"/>
-    <p:sldId xmlns:r="http://schemas.openxmlformats.org/officeDocument/2006/relationships" id="270" r:id="R83f8a8dcc0b940c2"/>
-    <p:sldId xmlns:r="http://schemas.openxmlformats.org/officeDocument/2006/relationships" id="271" r:id="Ra1f85339196c45e5"/>
-    <p:sldId xmlns:r="http://schemas.openxmlformats.org/officeDocument/2006/relationships" id="272" r:id="R80d8b52298e4429a"/>
-    <p:sldId xmlns:r="http://schemas.openxmlformats.org/officeDocument/2006/relationships" id="273" r:id="R648563cf5ac0469a"/>
-    <p:sldId xmlns:r="http://schemas.openxmlformats.org/officeDocument/2006/relationships" id="274" r:id="R1484e7ecbec949d8"/>
-    <p:sldId xmlns:r="http://schemas.openxmlformats.org/officeDocument/2006/relationships" id="275" r:id="Rb79833eaa2df4063"/>
-    <p:sldId xmlns:r="http://schemas.openxmlformats.org/officeDocument/2006/relationships" id="276" r:id="R1e45ea9a4fc241b8"/>
-    <p:sldId xmlns:r="http://schemas.openxmlformats.org/officeDocument/2006/relationships" id="277" r:id="R023748979ad74fa2"/>
+    <p:sldId xmlns:r="http://schemas.openxmlformats.org/officeDocument/2006/relationships" id="256" r:id="R7212e87c1bbc4287"/>
+    <p:sldId xmlns:r="http://schemas.openxmlformats.org/officeDocument/2006/relationships" id="257" r:id="R5f96e33df8574c9b"/>
+    <p:sldId xmlns:r="http://schemas.openxmlformats.org/officeDocument/2006/relationships" id="258" r:id="Reaf81f6b5d0b418b"/>
+    <p:sldId xmlns:r="http://schemas.openxmlformats.org/officeDocument/2006/relationships" id="259" r:id="R99aea0ace4594e50"/>
+    <p:sldId xmlns:r="http://schemas.openxmlformats.org/officeDocument/2006/relationships" id="260" r:id="R823f9d95f7f24cdf"/>
+    <p:sldId xmlns:r="http://schemas.openxmlformats.org/officeDocument/2006/relationships" id="261" r:id="R5d021e351ced42ee"/>
+    <p:sldId xmlns:r="http://schemas.openxmlformats.org/officeDocument/2006/relationships" id="262" r:id="R9d951a48f43e4eed"/>
+    <p:sldId xmlns:r="http://schemas.openxmlformats.org/officeDocument/2006/relationships" id="263" r:id="R6a413aff89d24e01"/>
+    <p:sldId xmlns:r="http://schemas.openxmlformats.org/officeDocument/2006/relationships" id="264" r:id="Ra1bc88cda042482c"/>
+    <p:sldId xmlns:r="http://schemas.openxmlformats.org/officeDocument/2006/relationships" id="265" r:id="R554767c3b17e4657"/>
+    <p:sldId xmlns:r="http://schemas.openxmlformats.org/officeDocument/2006/relationships" id="266" r:id="Rec59cac6e3144107"/>
+    <p:sldId xmlns:r="http://schemas.openxmlformats.org/officeDocument/2006/relationships" id="267" r:id="R237fe6a4e09d4e27"/>
+    <p:sldId xmlns:r="http://schemas.openxmlformats.org/officeDocument/2006/relationships" id="268" r:id="Rfd9521142524454c"/>
+    <p:sldId xmlns:r="http://schemas.openxmlformats.org/officeDocument/2006/relationships" id="269" r:id="Rd99be987902c40ce"/>
+    <p:sldId xmlns:r="http://schemas.openxmlformats.org/officeDocument/2006/relationships" id="270" r:id="Rbfe9c67ff6654487"/>
+    <p:sldId xmlns:r="http://schemas.openxmlformats.org/officeDocument/2006/relationships" id="271" r:id="R3874cdc829834b04"/>
+    <p:sldId xmlns:r="http://schemas.openxmlformats.org/officeDocument/2006/relationships" id="272" r:id="Ra384b90997be4046"/>
+    <p:sldId xmlns:r="http://schemas.openxmlformats.org/officeDocument/2006/relationships" id="273" r:id="R659747c324844c8f"/>
+    <p:sldId xmlns:r="http://schemas.openxmlformats.org/officeDocument/2006/relationships" id="274" r:id="R0113c65df5d440d8"/>
+    <p:sldId xmlns:r="http://schemas.openxmlformats.org/officeDocument/2006/relationships" id="275" r:id="Rb2caf02f508649d8"/>
+    <p:sldId xmlns:r="http://schemas.openxmlformats.org/officeDocument/2006/relationships" id="276" r:id="R03a13533ca024245"/>
+    <p:sldId xmlns:r="http://schemas.openxmlformats.org/officeDocument/2006/relationships" id="277" r:id="R964e11826ad64581"/>
   </p:sldIdLst>
   <p:sldSz cx="12192000" cy="6858000"/>
   <p:notesSz cx="6858000" cy="9144000"/>
   <p:embeddedFontLst>
     <p:embeddedFont>
       <p:font typeface="OpenAI Sans"/>
-      <p:regular xmlns:r="http://schemas.openxmlformats.org/officeDocument/2006/relationships" r:id="R28d6267d361b48d6"/>
-      <p:bold xmlns:r="http://schemas.openxmlformats.org/officeDocument/2006/relationships" r:id="Ra8af04b54b4345d6"/>
-      <p:italic xmlns:r="http://schemas.openxmlformats.org/officeDocument/2006/relationships" r:id="R4960771da5a049cf"/>
-      <p:boldItalic xmlns:r="http://schemas.openxmlformats.org/officeDocument/2006/relationships" r:id="Rb2e071fd818540bd"/>
+      <p:regular xmlns:r="http://schemas.openxmlformats.org/officeDocument/2006/relationships" r:id="Rf605d04f8e524b61"/>
+      <p:bold xmlns:r="http://schemas.openxmlformats.org/officeDocument/2006/relationships" r:id="R90952de796a5427c"/>
+      <p:italic xmlns:r="http://schemas.openxmlformats.org/officeDocument/2006/relationships" r:id="R49f3792868fd464e"/>
+      <p:boldItalic xmlns:r="http://schemas.openxmlformats.org/officeDocument/2006/relationships" r:id="Redc28b11f6a54118"/>
     </p:embeddedFont>
   </p:embeddedFontLst>
   <p:defaultTextStyle>
@@ -3005,36 +3005,6 @@
             </a:r>
             <a:endParaRPr/>
           </a:p>
-          <a:p xmlns:a="http://schemas.openxmlformats.org/drawingml/2006/main">
-            <a:pPr marL="0" lvl="0" indent="0" algn="l">
-              <a:spcBef>
-                <a:spcPts val="0"/>
-              </a:spcBef>
-              <a:spcAft>
-                <a:spcPts val="0"/>
-              </a:spcAft>
-              <a:buNone/>
-            </a:pPr>
-            <a:r>
-              <a:t/>
-            </a:r>
-            <a:endParaRPr/>
-          </a:p>
-          <a:p xmlns:a="http://schemas.openxmlformats.org/drawingml/2006/main">
-            <a:pPr marL="0" lvl="0" indent="0" algn="l">
-              <a:spcBef>
-                <a:spcPts val="0"/>
-              </a:spcBef>
-              <a:spcAft>
-                <a:spcPts val="0"/>
-              </a:spcAft>
-              <a:buNone/>
-            </a:pPr>
-            <a:r>
-              <a:t>3. Lookahead trades extra circuitry for less serial carry waiting; it does not make propagation delay disappear.</a:t>
-            </a:r>
-            <a:endParaRPr/>
-          </a:p>
         </p:txBody>
       </p:sp>
       <p:sp>
@@ -5985,14 +5955,14 @@
   </p:cSld>
   <p:clrMap bg1="dk1" tx1="lt1" bg2="dk2" tx2="lt2" accent1="accent1" accent2="accent2" accent3="accent3" accent4="accent4" accent5="accent5" accent6="accent6" hlink="hlink" folHlink="folHlink"/>
   <p:sldLayoutIdLst>
-    <p:sldLayoutId xmlns:r="http://schemas.openxmlformats.org/officeDocument/2006/relationships" id="2147483649" r:id="R29f3c32ccf024bba"/>
-    <p:sldLayoutId xmlns:r="http://schemas.openxmlformats.org/officeDocument/2006/relationships" id="2147483650" r:id="Rfe82a67123524ec7"/>
-    <p:sldLayoutId xmlns:r="http://schemas.openxmlformats.org/officeDocument/2006/relationships" id="2147483651" r:id="R764a44180c664fa7"/>
-    <p:sldLayoutId xmlns:r="http://schemas.openxmlformats.org/officeDocument/2006/relationships" id="2147483652" r:id="R5bbc885e11784e98"/>
-    <p:sldLayoutId xmlns:r="http://schemas.openxmlformats.org/officeDocument/2006/relationships" id="2147483653" r:id="R58f791987a7247e7"/>
-    <p:sldLayoutId xmlns:r="http://schemas.openxmlformats.org/officeDocument/2006/relationships" id="2147483654" r:id="R481cb4a3e68b4ea9"/>
-    <p:sldLayoutId xmlns:r="http://schemas.openxmlformats.org/officeDocument/2006/relationships" id="2147483655" r:id="Rd983b1f2b0cf4bce"/>
-    <p:sldLayoutId xmlns:r="http://schemas.openxmlformats.org/officeDocument/2006/relationships" id="2147483656" r:id="Rdd0664d47146485b"/>
+    <p:sldLayoutId xmlns:r="http://schemas.openxmlformats.org/officeDocument/2006/relationships" id="2147483649" r:id="R68d8640fc0bf4718"/>
+    <p:sldLayoutId xmlns:r="http://schemas.openxmlformats.org/officeDocument/2006/relationships" id="2147483650" r:id="R9ff3bff97c074c3b"/>
+    <p:sldLayoutId xmlns:r="http://schemas.openxmlformats.org/officeDocument/2006/relationships" id="2147483651" r:id="Rd0a9a8efed914327"/>
+    <p:sldLayoutId xmlns:r="http://schemas.openxmlformats.org/officeDocument/2006/relationships" id="2147483652" r:id="Rbe51dc8d30b046c0"/>
+    <p:sldLayoutId xmlns:r="http://schemas.openxmlformats.org/officeDocument/2006/relationships" id="2147483653" r:id="R23401447fdcb4f5f"/>
+    <p:sldLayoutId xmlns:r="http://schemas.openxmlformats.org/officeDocument/2006/relationships" id="2147483654" r:id="Rb4c27b008e094e24"/>
+    <p:sldLayoutId xmlns:r="http://schemas.openxmlformats.org/officeDocument/2006/relationships" id="2147483655" r:id="R32597ce987994ce8"/>
+    <p:sldLayoutId xmlns:r="http://schemas.openxmlformats.org/officeDocument/2006/relationships" id="2147483656" r:id="Rcc6f29ee4d004615"/>
   </p:sldLayoutIdLst>
   <p:hf hdr="0" dt="0"/>
   <p:txStyles>
@@ -8863,7 +8833,7 @@
           <p:cNvPr id="534" name="">
             <a:extLst xmlns:a="http://schemas.openxmlformats.org/drawingml/2006/main">
               <a:ext uri="{FF2B5EF4-FFF2-40B4-BE49-F238E27FC236}">
-                <a16:creationId xmlns:a16="http://schemas.microsoft.com/office/drawing/2014/main" id="{6126DCBC-E03C-4869-9646-67257DF6F56D}"/>
+                <a16:creationId xmlns:a16="http://schemas.microsoft.com/office/drawing/2014/main" id="{948FAC2A-C0F0-47A1-8480-66AE235B74A3}"/>
               </a:ext>
             </a:extLst>
           </p:cNvPr>
@@ -9606,7 +9576,7 @@
           <p:cNvPr id="535" name="Takeaway">
             <a:extLst xmlns:a="http://schemas.openxmlformats.org/drawingml/2006/main">
               <a:ext uri="{FF2B5EF4-FFF2-40B4-BE49-F238E27FC236}">
-                <a16:creationId xmlns:a16="http://schemas.microsoft.com/office/drawing/2014/main" id="{D1443A28-0C27-40CF-8121-EF986138E0D3}"/>
+                <a16:creationId xmlns:a16="http://schemas.microsoft.com/office/drawing/2014/main" id="{92E188C0-B2B3-4A7D-8EAD-F22D15C1025C}"/>
               </a:ext>
             </a:extLst>
           </p:cNvPr>
@@ -10990,7 +10960,7 @@
           <p:cNvPr id="534" name="Takeaway">
             <a:extLst xmlns:a="http://schemas.openxmlformats.org/drawingml/2006/main">
               <a:ext uri="{FF2B5EF4-FFF2-40B4-BE49-F238E27FC236}">
-                <a16:creationId xmlns:a16="http://schemas.microsoft.com/office/drawing/2014/main" id="{DC661101-C783-4BC7-AA3B-EE8733ED038C}"/>
+                <a16:creationId xmlns:a16="http://schemas.microsoft.com/office/drawing/2014/main" id="{F4BE7A76-DF7A-4FC5-8E87-0CACAEEF22A7}"/>
               </a:ext>
             </a:extLst>
           </p:cNvPr>
@@ -12423,7 +12393,7 @@
           <p:cNvPr id="534" name="Takeaway">
             <a:extLst xmlns:a="http://schemas.openxmlformats.org/drawingml/2006/main">
               <a:ext uri="{FF2B5EF4-FFF2-40B4-BE49-F238E27FC236}">
-                <a16:creationId xmlns:a16="http://schemas.microsoft.com/office/drawing/2014/main" id="{C807CC87-FE4E-45BF-907B-82A3C480A950}"/>
+                <a16:creationId xmlns:a16="http://schemas.microsoft.com/office/drawing/2014/main" id="{6A70441A-0A53-45B6-B30D-E349E0B76B64}"/>
               </a:ext>
             </a:extLst>
           </p:cNvPr>
@@ -13905,7 +13875,7 @@
           <p:cNvPr id="534" name="Takeaway">
             <a:extLst xmlns:a="http://schemas.openxmlformats.org/drawingml/2006/main">
               <a:ext uri="{FF2B5EF4-FFF2-40B4-BE49-F238E27FC236}">
-                <a16:creationId xmlns:a16="http://schemas.microsoft.com/office/drawing/2014/main" id="{7F882D58-6104-4A81-A780-76E8F7C406FE}"/>
+                <a16:creationId xmlns:a16="http://schemas.microsoft.com/office/drawing/2014/main" id="{2B084C75-3685-4DD1-BCE9-9CE1C6284BB2}"/>
               </a:ext>
             </a:extLst>
           </p:cNvPr>
@@ -15288,7 +15258,7 @@
           <p:cNvPr id="534" name="">
             <a:extLst xmlns:a="http://schemas.openxmlformats.org/drawingml/2006/main">
               <a:ext uri="{FF2B5EF4-FFF2-40B4-BE49-F238E27FC236}">
-                <a16:creationId xmlns:a16="http://schemas.microsoft.com/office/drawing/2014/main" id="{C3FDB7B7-EF09-4638-BC1D-A97AFF6EBD36}"/>
+                <a16:creationId xmlns:a16="http://schemas.microsoft.com/office/drawing/2014/main" id="{889B9E10-52BC-43FB-A9C2-A0B8BE542754}"/>
               </a:ext>
             </a:extLst>
           </p:cNvPr>
@@ -15648,7 +15618,7 @@
           <p:cNvPr id="535" name="Takeaway">
             <a:extLst xmlns:a="http://schemas.openxmlformats.org/drawingml/2006/main">
               <a:ext uri="{FF2B5EF4-FFF2-40B4-BE49-F238E27FC236}">
-                <a16:creationId xmlns:a16="http://schemas.microsoft.com/office/drawing/2014/main" id="{26446728-EABA-4E14-8CD8-CED6FC6ABE33}"/>
+                <a16:creationId xmlns:a16="http://schemas.microsoft.com/office/drawing/2014/main" id="{8FB76A11-5511-4B94-88C4-2B2B763A98AA}"/>
               </a:ext>
             </a:extLst>
           </p:cNvPr>
@@ -17098,7 +17068,7 @@
           <p:cNvPr id="534" name="Takeaway">
             <a:extLst xmlns:a="http://schemas.openxmlformats.org/drawingml/2006/main">
               <a:ext uri="{FF2B5EF4-FFF2-40B4-BE49-F238E27FC236}">
-                <a16:creationId xmlns:a16="http://schemas.microsoft.com/office/drawing/2014/main" id="{8F629B4C-85BF-4BCD-808E-A4824DFE98BF}"/>
+                <a16:creationId xmlns:a16="http://schemas.microsoft.com/office/drawing/2014/main" id="{3C48011C-488F-4C78-B598-E00FE8E6B473}"/>
               </a:ext>
             </a:extLst>
           </p:cNvPr>
@@ -18498,7 +18468,7 @@
           <p:cNvPr id="534" name="Takeaway">
             <a:extLst xmlns:a="http://schemas.openxmlformats.org/drawingml/2006/main">
               <a:ext uri="{FF2B5EF4-FFF2-40B4-BE49-F238E27FC236}">
-                <a16:creationId xmlns:a16="http://schemas.microsoft.com/office/drawing/2014/main" id="{B80853D7-6010-461D-BCF0-B69BAF7757FE}"/>
+                <a16:creationId xmlns:a16="http://schemas.microsoft.com/office/drawing/2014/main" id="{F8CCE1B6-FFA1-4B4C-AF7C-5CFFE28777B1}"/>
               </a:ext>
             </a:extLst>
           </p:cNvPr>
@@ -19948,7 +19918,7 @@
           <p:cNvPr id="534" name="Takeaway">
             <a:extLst xmlns:a="http://schemas.openxmlformats.org/drawingml/2006/main">
               <a:ext uri="{FF2B5EF4-FFF2-40B4-BE49-F238E27FC236}">
-                <a16:creationId xmlns:a16="http://schemas.microsoft.com/office/drawing/2014/main" id="{3AB64039-1C82-40A6-BCBA-0FF28061D2D8}"/>
+                <a16:creationId xmlns:a16="http://schemas.microsoft.com/office/drawing/2014/main" id="{94DCFC8A-EA52-4D5B-9106-BD7066C58056}"/>
               </a:ext>
             </a:extLst>
           </p:cNvPr>
@@ -21414,7 +21384,7 @@
           <p:cNvPr id="534" name="Takeaway">
             <a:extLst xmlns:a="http://schemas.openxmlformats.org/drawingml/2006/main">
               <a:ext uri="{FF2B5EF4-FFF2-40B4-BE49-F238E27FC236}">
-                <a16:creationId xmlns:a16="http://schemas.microsoft.com/office/drawing/2014/main" id="{391D6956-D8A2-4783-945F-6EEC3B572E63}"/>
+                <a16:creationId xmlns:a16="http://schemas.microsoft.com/office/drawing/2014/main" id="{E82237D0-8A9F-4B55-8A50-B1C56CF23423}"/>
               </a:ext>
             </a:extLst>
           </p:cNvPr>
@@ -22797,7 +22767,7 @@
           <p:cNvPr id="534" name="Takeaway">
             <a:extLst xmlns:a="http://schemas.openxmlformats.org/drawingml/2006/main">
               <a:ext uri="{FF2B5EF4-FFF2-40B4-BE49-F238E27FC236}">
-                <a16:creationId xmlns:a16="http://schemas.microsoft.com/office/drawing/2014/main" id="{088693FA-538C-4604-8AAE-CE245EFAFE41}"/>
+                <a16:creationId xmlns:a16="http://schemas.microsoft.com/office/drawing/2014/main" id="{28F56B6A-9F26-4E16-B4E9-072E52D5330B}"/>
               </a:ext>
             </a:extLst>
           </p:cNvPr>
@@ -24081,7 +24051,7 @@
           <p:cNvPr id="534" name="">
             <a:extLst xmlns:a="http://schemas.openxmlformats.org/drawingml/2006/main">
               <a:ext uri="{FF2B5EF4-FFF2-40B4-BE49-F238E27FC236}">
-                <a16:creationId xmlns:a16="http://schemas.microsoft.com/office/drawing/2014/main" id="{03179E62-FFE6-4C91-9F4F-8D38672E70F9}"/>
+                <a16:creationId xmlns:a16="http://schemas.microsoft.com/office/drawing/2014/main" id="{1CA9AB26-D5BA-4B49-AF36-8E0AAF4A9B48}"/>
               </a:ext>
             </a:extLst>
           </p:cNvPr>
@@ -24441,7 +24411,7 @@
           <p:cNvPr id="535" name="Takeaway">
             <a:extLst xmlns:a="http://schemas.openxmlformats.org/drawingml/2006/main">
               <a:ext uri="{FF2B5EF4-FFF2-40B4-BE49-F238E27FC236}">
-                <a16:creationId xmlns:a16="http://schemas.microsoft.com/office/drawing/2014/main" id="{3100A582-35DA-4603-B89F-1EC47260928D}"/>
+                <a16:creationId xmlns:a16="http://schemas.microsoft.com/office/drawing/2014/main" id="{256F5027-5C27-4E3B-8B5D-57EF5F14372E}"/>
               </a:ext>
             </a:extLst>
           </p:cNvPr>
@@ -25808,7 +25778,7 @@
           <p:cNvPr id="534" name="Takeaway">
             <a:extLst xmlns:a="http://schemas.openxmlformats.org/drawingml/2006/main">
               <a:ext uri="{FF2B5EF4-FFF2-40B4-BE49-F238E27FC236}">
-                <a16:creationId xmlns:a16="http://schemas.microsoft.com/office/drawing/2014/main" id="{A2E452FF-9994-4D14-A931-464BE5FC2262}"/>
+                <a16:creationId xmlns:a16="http://schemas.microsoft.com/office/drawing/2014/main" id="{FB8F47FD-3722-4CFC-890F-DD5D9E9A795B}"/>
               </a:ext>
             </a:extLst>
           </p:cNvPr>
@@ -27059,7 +27029,7 @@
           <p:cNvPr id="534" name="">
             <a:extLst xmlns:a="http://schemas.openxmlformats.org/drawingml/2006/main">
               <a:ext uri="{FF2B5EF4-FFF2-40B4-BE49-F238E27FC236}">
-                <a16:creationId xmlns:a16="http://schemas.microsoft.com/office/drawing/2014/main" id="{A012E9F3-5308-4C3A-9C19-7DE0AFD2C889}"/>
+                <a16:creationId xmlns:a16="http://schemas.microsoft.com/office/drawing/2014/main" id="{F673537E-2D02-4FDE-856A-3EBD9A61E031}"/>
               </a:ext>
             </a:extLst>
           </p:cNvPr>
@@ -28060,7 +28030,7 @@
           <p:cNvPr id="535" name="Takeaway">
             <a:extLst xmlns:a="http://schemas.openxmlformats.org/drawingml/2006/main">
               <a:ext uri="{FF2B5EF4-FFF2-40B4-BE49-F238E27FC236}">
-                <a16:creationId xmlns:a16="http://schemas.microsoft.com/office/drawing/2014/main" id="{525F78FC-4EDC-46D3-AC08-FC1461A3F460}"/>
+                <a16:creationId xmlns:a16="http://schemas.microsoft.com/office/drawing/2014/main" id="{4870899A-06FF-41E9-8B93-D98157C3747D}"/>
               </a:ext>
             </a:extLst>
           </p:cNvPr>
@@ -29493,7 +29463,7 @@
           <p:cNvPr id="534" name="Takeaway">
             <a:extLst xmlns:a="http://schemas.openxmlformats.org/drawingml/2006/main">
               <a:ext uri="{FF2B5EF4-FFF2-40B4-BE49-F238E27FC236}">
-                <a16:creationId xmlns:a16="http://schemas.microsoft.com/office/drawing/2014/main" id="{CFACD00C-15FA-4ADC-B5AA-67413F22CBFF}"/>
+                <a16:creationId xmlns:a16="http://schemas.microsoft.com/office/drawing/2014/main" id="{9E6E6410-3460-4CD9-8449-3E1ED9D20E57}"/>
               </a:ext>
             </a:extLst>
           </p:cNvPr>
@@ -30894,7 +30864,7 @@
           <p:cNvPr id="534" name="Takeaway">
             <a:extLst xmlns:a="http://schemas.openxmlformats.org/drawingml/2006/main">
               <a:ext uri="{FF2B5EF4-FFF2-40B4-BE49-F238E27FC236}">
-                <a16:creationId xmlns:a16="http://schemas.microsoft.com/office/drawing/2014/main" id="{8E7FD6EA-DD8C-469E-A422-AC9457977B48}"/>
+                <a16:creationId xmlns:a16="http://schemas.microsoft.com/office/drawing/2014/main" id="{277CFD7A-F486-4A4D-B0C8-A2A4B3BDB011}"/>
               </a:ext>
             </a:extLst>
           </p:cNvPr>
@@ -32310,7 +32280,7 @@
           <p:cNvPr id="534" name="Takeaway">
             <a:extLst xmlns:a="http://schemas.openxmlformats.org/drawingml/2006/main">
               <a:ext uri="{FF2B5EF4-FFF2-40B4-BE49-F238E27FC236}">
-                <a16:creationId xmlns:a16="http://schemas.microsoft.com/office/drawing/2014/main" id="{37E8A624-1B8E-4E81-A102-E31049CA9299}"/>
+                <a16:creationId xmlns:a16="http://schemas.microsoft.com/office/drawing/2014/main" id="{B856ED25-80AE-49DF-905B-F2F15E4626F0}"/>
               </a:ext>
             </a:extLst>
           </p:cNvPr>
@@ -33759,7 +33729,7 @@
           <p:cNvPr id="534" name="Takeaway">
             <a:extLst xmlns:a="http://schemas.openxmlformats.org/drawingml/2006/main">
               <a:ext uri="{FF2B5EF4-FFF2-40B4-BE49-F238E27FC236}">
-                <a16:creationId xmlns:a16="http://schemas.microsoft.com/office/drawing/2014/main" id="{E948C928-12C4-4381-A325-E7F56B1B2A08}"/>
+                <a16:creationId xmlns:a16="http://schemas.microsoft.com/office/drawing/2014/main" id="{3CF02E1F-EC25-46E4-910F-55FDB9995F10}"/>
               </a:ext>
             </a:extLst>
           </p:cNvPr>
@@ -35142,7 +35112,7 @@
           <p:cNvPr id="534" name="Takeaway">
             <a:extLst xmlns:a="http://schemas.openxmlformats.org/drawingml/2006/main">
               <a:ext uri="{FF2B5EF4-FFF2-40B4-BE49-F238E27FC236}">
-                <a16:creationId xmlns:a16="http://schemas.microsoft.com/office/drawing/2014/main" id="{9DC7F8A1-CD71-43C2-AAC8-6D5E7417A9CE}"/>
+                <a16:creationId xmlns:a16="http://schemas.microsoft.com/office/drawing/2014/main" id="{A3DEBD3D-2D8C-4A21-BFAE-4EEFF15F2BB1}"/>
               </a:ext>
             </a:extLst>
           </p:cNvPr>
@@ -36558,7 +36528,7 @@
           <p:cNvPr id="534" name="Takeaway">
             <a:extLst xmlns:a="http://schemas.openxmlformats.org/drawingml/2006/main">
               <a:ext uri="{FF2B5EF4-FFF2-40B4-BE49-F238E27FC236}">
-                <a16:creationId xmlns:a16="http://schemas.microsoft.com/office/drawing/2014/main" id="{32666288-B351-4C6A-BB14-A72BD39F5A15}"/>
+                <a16:creationId xmlns:a16="http://schemas.microsoft.com/office/drawing/2014/main" id="{8C7E06A6-FF64-4D12-BA7C-FE2003EDE72D}"/>
               </a:ext>
             </a:extLst>
           </p:cNvPr>
@@ -37975,7 +37945,7 @@
           <p:cNvPr id="534" name="Takeaway">
             <a:extLst xmlns:a="http://schemas.openxmlformats.org/drawingml/2006/main">
               <a:ext uri="{FF2B5EF4-FFF2-40B4-BE49-F238E27FC236}">
-                <a16:creationId xmlns:a16="http://schemas.microsoft.com/office/drawing/2014/main" id="{2D81D9CD-6125-4C20-8EBE-680FD8464A5B}"/>
+                <a16:creationId xmlns:a16="http://schemas.microsoft.com/office/drawing/2014/main" id="{2C95D011-3605-4821-BA17-84D455503E5E}"/>
               </a:ext>
             </a:extLst>
           </p:cNvPr>
@@ -39474,7 +39444,7 @@
           <p:cNvPr id="534" name="Takeaway">
             <a:extLst xmlns:a="http://schemas.openxmlformats.org/drawingml/2006/main">
               <a:ext uri="{FF2B5EF4-FFF2-40B4-BE49-F238E27FC236}">
-                <a16:creationId xmlns:a16="http://schemas.microsoft.com/office/drawing/2014/main" id="{ECC071D2-F7D0-45B7-98CD-046A82AB859D}"/>
+                <a16:creationId xmlns:a16="http://schemas.microsoft.com/office/drawing/2014/main" id="{6B2CA453-D4AC-4091-AEAF-8068EABD507F}"/>
               </a:ext>
             </a:extLst>
           </p:cNvPr>

</xml_diff>